<commit_message>
Paranda aastaarv esitlusel (2025 → 2026)
Co-Authored-By: Claude Sonnet 4.6 <noreply@anthropic.com>
</commit_message>
<xml_diff>
--- a/docs/esitlus.pptx
+++ b/docs/esitlus.pptx
@@ -5,14 +5,14 @@
     <p:sldMasterId id="2147483648" r:id="rId1"/>
   </p:sldMasterIdLst>
   <p:sldIdLst>
-    <p:sldId id="256" r:id="rId2"/>
-    <p:sldId id="257" r:id="rId3"/>
-    <p:sldId id="258" r:id="rId4"/>
-    <p:sldId id="259" r:id="rId5"/>
-    <p:sldId id="260" r:id="rId6"/>
-    <p:sldId id="261" r:id="rId7"/>
+    <p:sldId id="256" r:id="rId7"/>
+    <p:sldId id="257" r:id="rId8"/>
+    <p:sldId id="258" r:id="rId9"/>
+    <p:sldId id="259" r:id="rId10"/>
+    <p:sldId id="260" r:id="rId11"/>
+    <p:sldId id="261" r:id="rId12"/>
   </p:sldIdLst>
-  <p:sldSz cx="12188825" cy="6858000"/>
+  <p:sldSz cx="12188952" cy="6858000" type="screen4x3"/>
   <p:notesSz cx="6858000" cy="9144000"/>
   <p:defaultTextStyle>
     <a:defPPr>
@@ -109,91 +109,7 @@
       </a:defRPr>
     </a:lvl9pPr>
   </p:defaultTextStyle>
-  <p:extLst>
-    <p:ext uri="{EFAFB233-063F-42B5-8137-9DF3F51BA10A}">
-      <p15:sldGuideLst xmlns:p15="http://schemas.microsoft.com/office/powerpoint/2012/main">
-        <p15:guide id="1" orient="horz" pos="2160">
-          <p15:clr>
-            <a:srgbClr val="A4A3A4"/>
-          </p15:clr>
-        </p15:guide>
-        <p15:guide id="2" pos="2880">
-          <p15:clr>
-            <a:srgbClr val="A4A3A4"/>
-          </p15:clr>
-        </p15:guide>
-      </p15:sldGuideLst>
-    </p:ext>
-  </p:extLst>
 </p:presentation>
-</file>
-
-<file path=ppt/changesInfos/changesInfo1.xml><?xml version="1.0" encoding="utf-8"?>
-<pc:chgInfo xmlns:a="http://schemas.openxmlformats.org/drawingml/2006/main" xmlns:r="http://schemas.openxmlformats.org/officeDocument/2006/relationships" xmlns:ac="http://schemas.microsoft.com/office/drawing/2013/main/command" xmlns:pc="http://schemas.microsoft.com/office/powerpoint/2013/main/command">
-  <pc:docChgLst>
-    <pc:chgData name="Mihkel Nugis" userId="147e2f29-4501-45b3-8d2b-0a3f0bc4fbae" providerId="ADAL" clId="{19F9C2E8-51A5-4117-AA1C-CDF822D93710}"/>
-    <pc:docChg chg="modSld">
-      <pc:chgData name="Mihkel Nugis" userId="147e2f29-4501-45b3-8d2b-0a3f0bc4fbae" providerId="ADAL" clId="{19F9C2E8-51A5-4117-AA1C-CDF822D93710}" dt="2026-06-06T15:01:06.506" v="27" actId="1037"/>
-      <pc:docMkLst>
-        <pc:docMk/>
-      </pc:docMkLst>
-      <pc:sldChg chg="modSp mod">
-        <pc:chgData name="Mihkel Nugis" userId="147e2f29-4501-45b3-8d2b-0a3f0bc4fbae" providerId="ADAL" clId="{19F9C2E8-51A5-4117-AA1C-CDF822D93710}" dt="2026-06-06T15:00:45.453" v="19" actId="1035"/>
-        <pc:sldMkLst>
-          <pc:docMk/>
-          <pc:sldMk cId="0" sldId="256"/>
-        </pc:sldMkLst>
-        <pc:spChg chg="mod">
-          <ac:chgData name="Mihkel Nugis" userId="147e2f29-4501-45b3-8d2b-0a3f0bc4fbae" providerId="ADAL" clId="{19F9C2E8-51A5-4117-AA1C-CDF822D93710}" dt="2026-06-06T15:00:45.453" v="19" actId="1035"/>
-          <ac:spMkLst>
-            <pc:docMk/>
-            <pc:sldMk cId="0" sldId="256"/>
-            <ac:spMk id="2" creationId="{00000000-0000-0000-0000-000000000000}"/>
-          </ac:spMkLst>
-        </pc:spChg>
-      </pc:sldChg>
-      <pc:sldChg chg="modSp mod">
-        <pc:chgData name="Mihkel Nugis" userId="147e2f29-4501-45b3-8d2b-0a3f0bc4fbae" providerId="ADAL" clId="{19F9C2E8-51A5-4117-AA1C-CDF822D93710}" dt="2026-06-06T15:01:06.506" v="27" actId="1037"/>
-        <pc:sldMkLst>
-          <pc:docMk/>
-          <pc:sldMk cId="0" sldId="259"/>
-        </pc:sldMkLst>
-        <pc:spChg chg="mod">
-          <ac:chgData name="Mihkel Nugis" userId="147e2f29-4501-45b3-8d2b-0a3f0bc4fbae" providerId="ADAL" clId="{19F9C2E8-51A5-4117-AA1C-CDF822D93710}" dt="2026-06-06T15:01:06.506" v="27" actId="1037"/>
-          <ac:spMkLst>
-            <pc:docMk/>
-            <pc:sldMk cId="0" sldId="259"/>
-            <ac:spMk id="7" creationId="{00000000-0000-0000-0000-000000000000}"/>
-          </ac:spMkLst>
-        </pc:spChg>
-        <pc:spChg chg="mod">
-          <ac:chgData name="Mihkel Nugis" userId="147e2f29-4501-45b3-8d2b-0a3f0bc4fbae" providerId="ADAL" clId="{19F9C2E8-51A5-4117-AA1C-CDF822D93710}" dt="2026-06-06T15:01:06.506" v="27" actId="1037"/>
-          <ac:spMkLst>
-            <pc:docMk/>
-            <pc:sldMk cId="0" sldId="259"/>
-            <ac:spMk id="11" creationId="{00000000-0000-0000-0000-000000000000}"/>
-          </ac:spMkLst>
-        </pc:spChg>
-        <pc:spChg chg="mod">
-          <ac:chgData name="Mihkel Nugis" userId="147e2f29-4501-45b3-8d2b-0a3f0bc4fbae" providerId="ADAL" clId="{19F9C2E8-51A5-4117-AA1C-CDF822D93710}" dt="2026-06-06T15:01:06.506" v="27" actId="1037"/>
-          <ac:spMkLst>
-            <pc:docMk/>
-            <pc:sldMk cId="0" sldId="259"/>
-            <ac:spMk id="15" creationId="{00000000-0000-0000-0000-000000000000}"/>
-          </ac:spMkLst>
-        </pc:spChg>
-        <pc:spChg chg="mod">
-          <ac:chgData name="Mihkel Nugis" userId="147e2f29-4501-45b3-8d2b-0a3f0bc4fbae" providerId="ADAL" clId="{19F9C2E8-51A5-4117-AA1C-CDF822D93710}" dt="2026-06-06T15:01:06.506" v="27" actId="1037"/>
-          <ac:spMkLst>
-            <pc:docMk/>
-            <pc:sldMk cId="0" sldId="259"/>
-            <ac:spMk id="19" creationId="{00000000-0000-0000-0000-000000000000}"/>
-          </ac:spMkLst>
-        </pc:spChg>
-      </pc:sldChg>
-    </pc:docChg>
-  </pc:docChgLst>
-</pc:chgInfo>
 </file>
 
 <file path=ppt/slideLayouts/slideLayout1.xml><?xml version="1.0" encoding="utf-8"?>
@@ -234,9 +150,10 @@
           <a:lstStyle/>
           <a:p>
             <a:r>
-              <a:rPr lang="en-US"/>
+              <a:rPr lang="en-US" smtClean="0"/>
               <a:t>Click to edit Master title style</a:t>
             </a:r>
+            <a:endParaRPr lang="en-US"/>
           </a:p>
         </p:txBody>
       </p:sp>
@@ -352,9 +269,10 @@
           </a:lstStyle>
           <a:p>
             <a:r>
-              <a:rPr lang="en-US"/>
+              <a:rPr lang="en-US" smtClean="0"/>
               <a:t>Click to edit Master subtitle style</a:t>
             </a:r>
+            <a:endParaRPr lang="en-US"/>
           </a:p>
         </p:txBody>
       </p:sp>
@@ -375,7 +293,7 @@
           <a:p>
             <a:fld id="{5BCAD085-E8A6-8845-BD4E-CB4CCA059FC4}" type="datetimeFigureOut">
               <a:rPr lang="en-US" smtClean="0"/>
-              <a:t>6/6/2026</a:t>
+              <a:t>1/27/13</a:t>
             </a:fld>
             <a:endParaRPr lang="en-US"/>
           </a:p>
@@ -469,9 +387,10 @@
           <a:lstStyle/>
           <a:p>
             <a:r>
-              <a:rPr lang="en-US"/>
+              <a:rPr lang="en-US" smtClean="0"/>
               <a:t>Click to edit Master title style</a:t>
             </a:r>
+            <a:endParaRPr lang="en-US"/>
           </a:p>
         </p:txBody>
       </p:sp>
@@ -492,37 +411,38 @@
           <a:p>
             <a:pPr lvl="0"/>
             <a:r>
-              <a:rPr lang="en-US"/>
+              <a:rPr lang="en-US" smtClean="0"/>
               <a:t>Click to edit Master text styles</a:t>
             </a:r>
           </a:p>
           <a:p>
             <a:pPr lvl="1"/>
             <a:r>
-              <a:rPr lang="en-US"/>
+              <a:rPr lang="en-US" smtClean="0"/>
               <a:t>Second level</a:t>
             </a:r>
           </a:p>
           <a:p>
             <a:pPr lvl="2"/>
             <a:r>
-              <a:rPr lang="en-US"/>
+              <a:rPr lang="en-US" smtClean="0"/>
               <a:t>Third level</a:t>
             </a:r>
           </a:p>
           <a:p>
             <a:pPr lvl="3"/>
             <a:r>
-              <a:rPr lang="en-US"/>
+              <a:rPr lang="en-US" smtClean="0"/>
               <a:t>Fourth level</a:t>
             </a:r>
           </a:p>
           <a:p>
             <a:pPr lvl="4"/>
             <a:r>
-              <a:rPr lang="en-US"/>
+              <a:rPr lang="en-US" smtClean="0"/>
               <a:t>Fifth level</a:t>
             </a:r>
+            <a:endParaRPr lang="en-US"/>
           </a:p>
         </p:txBody>
       </p:sp>
@@ -543,7 +463,7 @@
           <a:p>
             <a:fld id="{5BCAD085-E8A6-8845-BD4E-CB4CCA059FC4}" type="datetimeFigureOut">
               <a:rPr lang="en-US" smtClean="0"/>
-              <a:t>6/6/2026</a:t>
+              <a:t>1/27/13</a:t>
             </a:fld>
             <a:endParaRPr lang="en-US"/>
           </a:p>
@@ -642,9 +562,10 @@
           <a:lstStyle/>
           <a:p>
             <a:r>
-              <a:rPr lang="en-US"/>
+              <a:rPr lang="en-US" smtClean="0"/>
               <a:t>Click to edit Master title style</a:t>
             </a:r>
+            <a:endParaRPr lang="en-US"/>
           </a:p>
         </p:txBody>
       </p:sp>
@@ -670,37 +591,38 @@
           <a:p>
             <a:pPr lvl="0"/>
             <a:r>
-              <a:rPr lang="en-US"/>
+              <a:rPr lang="en-US" smtClean="0"/>
               <a:t>Click to edit Master text styles</a:t>
             </a:r>
           </a:p>
           <a:p>
             <a:pPr lvl="1"/>
             <a:r>
-              <a:rPr lang="en-US"/>
+              <a:rPr lang="en-US" smtClean="0"/>
               <a:t>Second level</a:t>
             </a:r>
           </a:p>
           <a:p>
             <a:pPr lvl="2"/>
             <a:r>
-              <a:rPr lang="en-US"/>
+              <a:rPr lang="en-US" smtClean="0"/>
               <a:t>Third level</a:t>
             </a:r>
           </a:p>
           <a:p>
             <a:pPr lvl="3"/>
             <a:r>
-              <a:rPr lang="en-US"/>
+              <a:rPr lang="en-US" smtClean="0"/>
               <a:t>Fourth level</a:t>
             </a:r>
           </a:p>
           <a:p>
             <a:pPr lvl="4"/>
             <a:r>
-              <a:rPr lang="en-US"/>
+              <a:rPr lang="en-US" smtClean="0"/>
               <a:t>Fifth level</a:t>
             </a:r>
+            <a:endParaRPr lang="en-US"/>
           </a:p>
         </p:txBody>
       </p:sp>
@@ -721,7 +643,7 @@
           <a:p>
             <a:fld id="{5BCAD085-E8A6-8845-BD4E-CB4CCA059FC4}" type="datetimeFigureOut">
               <a:rPr lang="en-US" smtClean="0"/>
-              <a:t>6/6/2026</a:t>
+              <a:t>1/27/13</a:t>
             </a:fld>
             <a:endParaRPr lang="en-US"/>
           </a:p>
@@ -815,9 +737,10 @@
           <a:lstStyle/>
           <a:p>
             <a:r>
-              <a:rPr lang="en-US"/>
+              <a:rPr lang="en-US" smtClean="0"/>
               <a:t>Click to edit Master title style</a:t>
             </a:r>
+            <a:endParaRPr lang="en-US"/>
           </a:p>
         </p:txBody>
       </p:sp>
@@ -838,37 +761,38 @@
           <a:p>
             <a:pPr lvl="0"/>
             <a:r>
-              <a:rPr lang="en-US"/>
+              <a:rPr lang="en-US" smtClean="0"/>
               <a:t>Click to edit Master text styles</a:t>
             </a:r>
           </a:p>
           <a:p>
             <a:pPr lvl="1"/>
             <a:r>
-              <a:rPr lang="en-US"/>
+              <a:rPr lang="en-US" smtClean="0"/>
               <a:t>Second level</a:t>
             </a:r>
           </a:p>
           <a:p>
             <a:pPr lvl="2"/>
             <a:r>
-              <a:rPr lang="en-US"/>
+              <a:rPr lang="en-US" smtClean="0"/>
               <a:t>Third level</a:t>
             </a:r>
           </a:p>
           <a:p>
             <a:pPr lvl="3"/>
             <a:r>
-              <a:rPr lang="en-US"/>
+              <a:rPr lang="en-US" smtClean="0"/>
               <a:t>Fourth level</a:t>
             </a:r>
           </a:p>
           <a:p>
             <a:pPr lvl="4"/>
             <a:r>
-              <a:rPr lang="en-US"/>
+              <a:rPr lang="en-US" smtClean="0"/>
               <a:t>Fifth level</a:t>
             </a:r>
+            <a:endParaRPr lang="en-US"/>
           </a:p>
         </p:txBody>
       </p:sp>
@@ -889,7 +813,7 @@
           <a:p>
             <a:fld id="{5BCAD085-E8A6-8845-BD4E-CB4CCA059FC4}" type="datetimeFigureOut">
               <a:rPr lang="en-US" smtClean="0"/>
-              <a:t>6/6/2026</a:t>
+              <a:t>1/27/13</a:t>
             </a:fld>
             <a:endParaRPr lang="en-US"/>
           </a:p>
@@ -992,9 +916,10 @@
           </a:lstStyle>
           <a:p>
             <a:r>
-              <a:rPr lang="en-US"/>
+              <a:rPr lang="en-US" smtClean="0"/>
               <a:t>Click to edit Master title style</a:t>
             </a:r>
+            <a:endParaRPr lang="en-US"/>
           </a:p>
         </p:txBody>
       </p:sp>
@@ -1111,7 +1036,7 @@
           <a:p>
             <a:pPr lvl="0"/>
             <a:r>
-              <a:rPr lang="en-US"/>
+              <a:rPr lang="en-US" smtClean="0"/>
               <a:t>Click to edit Master text styles</a:t>
             </a:r>
           </a:p>
@@ -1134,7 +1059,7 @@
           <a:p>
             <a:fld id="{5BCAD085-E8A6-8845-BD4E-CB4CCA059FC4}" type="datetimeFigureOut">
               <a:rPr lang="en-US" smtClean="0"/>
-              <a:t>6/6/2026</a:t>
+              <a:t>1/27/13</a:t>
             </a:fld>
             <a:endParaRPr lang="en-US"/>
           </a:p>
@@ -1228,9 +1153,10 @@
           <a:lstStyle/>
           <a:p>
             <a:r>
-              <a:rPr lang="en-US"/>
+              <a:rPr lang="en-US" smtClean="0"/>
               <a:t>Click to edit Master title style</a:t>
             </a:r>
+            <a:endParaRPr lang="en-US"/>
           </a:p>
         </p:txBody>
       </p:sp>
@@ -1284,37 +1210,38 @@
           <a:p>
             <a:pPr lvl="0"/>
             <a:r>
-              <a:rPr lang="en-US"/>
+              <a:rPr lang="en-US" smtClean="0"/>
               <a:t>Click to edit Master text styles</a:t>
             </a:r>
           </a:p>
           <a:p>
             <a:pPr lvl="1"/>
             <a:r>
-              <a:rPr lang="en-US"/>
+              <a:rPr lang="en-US" smtClean="0"/>
               <a:t>Second level</a:t>
             </a:r>
           </a:p>
           <a:p>
             <a:pPr lvl="2"/>
             <a:r>
-              <a:rPr lang="en-US"/>
+              <a:rPr lang="en-US" smtClean="0"/>
               <a:t>Third level</a:t>
             </a:r>
           </a:p>
           <a:p>
             <a:pPr lvl="3"/>
             <a:r>
-              <a:rPr lang="en-US"/>
+              <a:rPr lang="en-US" smtClean="0"/>
               <a:t>Fourth level</a:t>
             </a:r>
           </a:p>
           <a:p>
             <a:pPr lvl="4"/>
             <a:r>
-              <a:rPr lang="en-US"/>
+              <a:rPr lang="en-US" smtClean="0"/>
               <a:t>Fifth level</a:t>
             </a:r>
+            <a:endParaRPr lang="en-US"/>
           </a:p>
         </p:txBody>
       </p:sp>
@@ -1368,37 +1295,38 @@
           <a:p>
             <a:pPr lvl="0"/>
             <a:r>
-              <a:rPr lang="en-US"/>
+              <a:rPr lang="en-US" smtClean="0"/>
               <a:t>Click to edit Master text styles</a:t>
             </a:r>
           </a:p>
           <a:p>
             <a:pPr lvl="1"/>
             <a:r>
-              <a:rPr lang="en-US"/>
+              <a:rPr lang="en-US" smtClean="0"/>
               <a:t>Second level</a:t>
             </a:r>
           </a:p>
           <a:p>
             <a:pPr lvl="2"/>
             <a:r>
-              <a:rPr lang="en-US"/>
+              <a:rPr lang="en-US" smtClean="0"/>
               <a:t>Third level</a:t>
             </a:r>
           </a:p>
           <a:p>
             <a:pPr lvl="3"/>
             <a:r>
-              <a:rPr lang="en-US"/>
+              <a:rPr lang="en-US" smtClean="0"/>
               <a:t>Fourth level</a:t>
             </a:r>
           </a:p>
           <a:p>
             <a:pPr lvl="4"/>
             <a:r>
-              <a:rPr lang="en-US"/>
+              <a:rPr lang="en-US" smtClean="0"/>
               <a:t>Fifth level</a:t>
             </a:r>
+            <a:endParaRPr lang="en-US"/>
           </a:p>
         </p:txBody>
       </p:sp>
@@ -1419,7 +1347,7 @@
           <a:p>
             <a:fld id="{5BCAD085-E8A6-8845-BD4E-CB4CCA059FC4}" type="datetimeFigureOut">
               <a:rPr lang="en-US" smtClean="0"/>
-              <a:t>6/6/2026</a:t>
+              <a:t>1/27/13</a:t>
             </a:fld>
             <a:endParaRPr lang="en-US"/>
           </a:p>
@@ -1517,9 +1445,10 @@
           </a:lstStyle>
           <a:p>
             <a:r>
-              <a:rPr lang="en-US"/>
+              <a:rPr lang="en-US" smtClean="0"/>
               <a:t>Click to edit Master title style</a:t>
             </a:r>
+            <a:endParaRPr lang="en-US"/>
           </a:p>
         </p:txBody>
       </p:sp>
@@ -1582,7 +1511,7 @@
           <a:p>
             <a:pPr lvl="0"/>
             <a:r>
-              <a:rPr lang="en-US"/>
+              <a:rPr lang="en-US" smtClean="0"/>
               <a:t>Click to edit Master text styles</a:t>
             </a:r>
           </a:p>
@@ -1638,37 +1567,38 @@
           <a:p>
             <a:pPr lvl="0"/>
             <a:r>
-              <a:rPr lang="en-US"/>
+              <a:rPr lang="en-US" smtClean="0"/>
               <a:t>Click to edit Master text styles</a:t>
             </a:r>
           </a:p>
           <a:p>
             <a:pPr lvl="1"/>
             <a:r>
-              <a:rPr lang="en-US"/>
+              <a:rPr lang="en-US" smtClean="0"/>
               <a:t>Second level</a:t>
             </a:r>
           </a:p>
           <a:p>
             <a:pPr lvl="2"/>
             <a:r>
-              <a:rPr lang="en-US"/>
+              <a:rPr lang="en-US" smtClean="0"/>
               <a:t>Third level</a:t>
             </a:r>
           </a:p>
           <a:p>
             <a:pPr lvl="3"/>
             <a:r>
-              <a:rPr lang="en-US"/>
+              <a:rPr lang="en-US" smtClean="0"/>
               <a:t>Fourth level</a:t>
             </a:r>
           </a:p>
           <a:p>
             <a:pPr lvl="4"/>
             <a:r>
-              <a:rPr lang="en-US"/>
+              <a:rPr lang="en-US" smtClean="0"/>
               <a:t>Fifth level</a:t>
             </a:r>
+            <a:endParaRPr lang="en-US"/>
           </a:p>
         </p:txBody>
       </p:sp>
@@ -1731,7 +1661,7 @@
           <a:p>
             <a:pPr lvl="0"/>
             <a:r>
-              <a:rPr lang="en-US"/>
+              <a:rPr lang="en-US" smtClean="0"/>
               <a:t>Click to edit Master text styles</a:t>
             </a:r>
           </a:p>
@@ -1787,37 +1717,38 @@
           <a:p>
             <a:pPr lvl="0"/>
             <a:r>
-              <a:rPr lang="en-US"/>
+              <a:rPr lang="en-US" smtClean="0"/>
               <a:t>Click to edit Master text styles</a:t>
             </a:r>
           </a:p>
           <a:p>
             <a:pPr lvl="1"/>
             <a:r>
-              <a:rPr lang="en-US"/>
+              <a:rPr lang="en-US" smtClean="0"/>
               <a:t>Second level</a:t>
             </a:r>
           </a:p>
           <a:p>
             <a:pPr lvl="2"/>
             <a:r>
-              <a:rPr lang="en-US"/>
+              <a:rPr lang="en-US" smtClean="0"/>
               <a:t>Third level</a:t>
             </a:r>
           </a:p>
           <a:p>
             <a:pPr lvl="3"/>
             <a:r>
-              <a:rPr lang="en-US"/>
+              <a:rPr lang="en-US" smtClean="0"/>
               <a:t>Fourth level</a:t>
             </a:r>
           </a:p>
           <a:p>
             <a:pPr lvl="4"/>
             <a:r>
-              <a:rPr lang="en-US"/>
+              <a:rPr lang="en-US" smtClean="0"/>
               <a:t>Fifth level</a:t>
             </a:r>
+            <a:endParaRPr lang="en-US"/>
           </a:p>
         </p:txBody>
       </p:sp>
@@ -1838,7 +1769,7 @@
           <a:p>
             <a:fld id="{5BCAD085-E8A6-8845-BD4E-CB4CCA059FC4}" type="datetimeFigureOut">
               <a:rPr lang="en-US" smtClean="0"/>
-              <a:t>6/6/2026</a:t>
+              <a:t>1/27/13</a:t>
             </a:fld>
             <a:endParaRPr lang="en-US"/>
           </a:p>
@@ -1932,9 +1863,10 @@
           <a:lstStyle/>
           <a:p>
             <a:r>
-              <a:rPr lang="en-US"/>
+              <a:rPr lang="en-US" smtClean="0"/>
               <a:t>Click to edit Master title style</a:t>
             </a:r>
+            <a:endParaRPr lang="en-US"/>
           </a:p>
         </p:txBody>
       </p:sp>
@@ -1955,7 +1887,7 @@
           <a:p>
             <a:fld id="{5BCAD085-E8A6-8845-BD4E-CB4CCA059FC4}" type="datetimeFigureOut">
               <a:rPr lang="en-US" smtClean="0"/>
-              <a:t>6/6/2026</a:t>
+              <a:t>1/27/13</a:t>
             </a:fld>
             <a:endParaRPr lang="en-US"/>
           </a:p>
@@ -2050,7 +1982,7 @@
           <a:p>
             <a:fld id="{5BCAD085-E8A6-8845-BD4E-CB4CCA059FC4}" type="datetimeFigureOut">
               <a:rPr lang="en-US" smtClean="0"/>
-              <a:t>6/6/2026</a:t>
+              <a:t>1/27/13</a:t>
             </a:fld>
             <a:endParaRPr lang="en-US"/>
           </a:p>
@@ -2153,9 +2085,10 @@
           </a:lstStyle>
           <a:p>
             <a:r>
-              <a:rPr lang="en-US"/>
+              <a:rPr lang="en-US" smtClean="0"/>
               <a:t>Click to edit Master title style</a:t>
             </a:r>
+            <a:endParaRPr lang="en-US"/>
           </a:p>
         </p:txBody>
       </p:sp>
@@ -2209,37 +2142,38 @@
           <a:p>
             <a:pPr lvl="0"/>
             <a:r>
-              <a:rPr lang="en-US"/>
+              <a:rPr lang="en-US" smtClean="0"/>
               <a:t>Click to edit Master text styles</a:t>
             </a:r>
           </a:p>
           <a:p>
             <a:pPr lvl="1"/>
             <a:r>
-              <a:rPr lang="en-US"/>
+              <a:rPr lang="en-US" smtClean="0"/>
               <a:t>Second level</a:t>
             </a:r>
           </a:p>
           <a:p>
             <a:pPr lvl="2"/>
             <a:r>
-              <a:rPr lang="en-US"/>
+              <a:rPr lang="en-US" smtClean="0"/>
               <a:t>Third level</a:t>
             </a:r>
           </a:p>
           <a:p>
             <a:pPr lvl="3"/>
             <a:r>
-              <a:rPr lang="en-US"/>
+              <a:rPr lang="en-US" smtClean="0"/>
               <a:t>Fourth level</a:t>
             </a:r>
           </a:p>
           <a:p>
             <a:pPr lvl="4"/>
             <a:r>
-              <a:rPr lang="en-US"/>
+              <a:rPr lang="en-US" smtClean="0"/>
               <a:t>Fifth level</a:t>
             </a:r>
+            <a:endParaRPr lang="en-US"/>
           </a:p>
         </p:txBody>
       </p:sp>
@@ -2302,7 +2236,7 @@
           <a:p>
             <a:pPr lvl="0"/>
             <a:r>
-              <a:rPr lang="en-US"/>
+              <a:rPr lang="en-US" smtClean="0"/>
               <a:t>Click to edit Master text styles</a:t>
             </a:r>
           </a:p>
@@ -2325,7 +2259,7 @@
           <a:p>
             <a:fld id="{5BCAD085-E8A6-8845-BD4E-CB4CCA059FC4}" type="datetimeFigureOut">
               <a:rPr lang="en-US" smtClean="0"/>
-              <a:t>6/6/2026</a:t>
+              <a:t>1/27/13</a:t>
             </a:fld>
             <a:endParaRPr lang="en-US"/>
           </a:p>
@@ -2428,9 +2362,10 @@
           </a:lstStyle>
           <a:p>
             <a:r>
-              <a:rPr lang="en-US"/>
+              <a:rPr lang="en-US" smtClean="0"/>
               <a:t>Click to edit Master title style</a:t>
             </a:r>
+            <a:endParaRPr lang="en-US"/>
           </a:p>
         </p:txBody>
       </p:sp>
@@ -2554,7 +2489,7 @@
           <a:p>
             <a:pPr lvl="0"/>
             <a:r>
-              <a:rPr lang="en-US"/>
+              <a:rPr lang="en-US" smtClean="0"/>
               <a:t>Click to edit Master text styles</a:t>
             </a:r>
           </a:p>
@@ -2577,7 +2512,7 @@
           <a:p>
             <a:fld id="{5BCAD085-E8A6-8845-BD4E-CB4CCA059FC4}" type="datetimeFigureOut">
               <a:rPr lang="en-US" smtClean="0"/>
-              <a:t>6/6/2026</a:t>
+              <a:t>1/27/13</a:t>
             </a:fld>
             <a:endParaRPr lang="en-US"/>
           </a:p>
@@ -2686,9 +2621,10 @@
           <a:lstStyle/>
           <a:p>
             <a:r>
-              <a:rPr lang="en-US"/>
+              <a:rPr lang="en-US" smtClean="0"/>
               <a:t>Click to edit Master title style</a:t>
             </a:r>
+            <a:endParaRPr lang="en-US"/>
           </a:p>
         </p:txBody>
       </p:sp>
@@ -2719,37 +2655,38 @@
           <a:p>
             <a:pPr lvl="0"/>
             <a:r>
-              <a:rPr lang="en-US"/>
+              <a:rPr lang="en-US" smtClean="0"/>
               <a:t>Click to edit Master text styles</a:t>
             </a:r>
           </a:p>
           <a:p>
             <a:pPr lvl="1"/>
             <a:r>
-              <a:rPr lang="en-US"/>
+              <a:rPr lang="en-US" smtClean="0"/>
               <a:t>Second level</a:t>
             </a:r>
           </a:p>
           <a:p>
             <a:pPr lvl="2"/>
             <a:r>
-              <a:rPr lang="en-US"/>
+              <a:rPr lang="en-US" smtClean="0"/>
               <a:t>Third level</a:t>
             </a:r>
           </a:p>
           <a:p>
             <a:pPr lvl="3"/>
             <a:r>
-              <a:rPr lang="en-US"/>
+              <a:rPr lang="en-US" smtClean="0"/>
               <a:t>Fourth level</a:t>
             </a:r>
           </a:p>
           <a:p>
             <a:pPr lvl="4"/>
             <a:r>
-              <a:rPr lang="en-US"/>
+              <a:rPr lang="en-US" smtClean="0"/>
               <a:t>Fifth level</a:t>
             </a:r>
+            <a:endParaRPr lang="en-US"/>
           </a:p>
         </p:txBody>
       </p:sp>
@@ -2788,7 +2725,7 @@
           <a:p>
             <a:fld id="{5BCAD085-E8A6-8845-BD4E-CB4CCA059FC4}" type="datetimeFigureOut">
               <a:rPr lang="en-US" smtClean="0"/>
-              <a:t>6/6/2026</a:t>
+              <a:t>1/27/13</a:t>
             </a:fld>
             <a:endParaRPr lang="en-US"/>
           </a:p>
@@ -3147,7 +3084,7 @@
 </file>
 
 <file path=ppt/slides/slide1.xml><?xml version="1.0" encoding="utf-8"?>
-<p:sld xmlns:a="http://schemas.openxmlformats.org/drawingml/2006/main" xmlns:r="http://schemas.openxmlformats.org/officeDocument/2006/relationships" xmlns:p="http://schemas.openxmlformats.org/presentationml/2006/main">
+<p:sld xmlns:a="http://schemas.openxmlformats.org/drawingml/2006/main" xmlns:p="http://schemas.openxmlformats.org/presentationml/2006/main" xmlns:r="http://schemas.openxmlformats.org/officeDocument/2006/relationships">
   <p:cSld>
     <p:bg>
       <p:bgPr>
@@ -3163,14 +3100,7 @@
         <p:cNvGrpSpPr/>
         <p:nvPr/>
       </p:nvGrpSpPr>
-      <p:grpSpPr>
-        <a:xfrm>
-          <a:off x="0" y="0"/>
-          <a:ext cx="0" cy="0"/>
-          <a:chOff x="0" y="0"/>
-          <a:chExt cx="0" cy="0"/>
-        </a:xfrm>
-      </p:grpSpPr>
+      <p:grpSpPr/>
       <p:sp>
         <p:nvSpPr>
           <p:cNvPr id="2" name="Rectangle 1"/>
@@ -3179,7 +3109,7 @@
         </p:nvSpPr>
         <p:spPr>
           <a:xfrm>
-            <a:off x="0" y="2322576"/>
+            <a:off x="0" y="2743200"/>
             <a:ext cx="12188952" cy="64008"/>
           </a:xfrm>
           <a:prstGeom prst="rect">
@@ -3211,7 +3141,6 @@
           <a:lstStyle/>
           <a:p>
             <a:pPr algn="ctr"/>
-            <a:endParaRPr/>
           </a:p>
         </p:txBody>
       </p:sp>
@@ -3278,7 +3207,7 @@
                   <a:srgbClr val="BDD7EE"/>
                 </a:solidFill>
               </a:rPr>
-              <a:t>Andmeinseneeria kursuse grupitöö  ·  2025</a:t>
+              <a:t>Andmeinseneeria kursuse grupitöö  ·  2026</a:t>
             </a:r>
           </a:p>
         </p:txBody>
@@ -3361,7 +3290,7 @@
 </file>
 
 <file path=ppt/slides/slide2.xml><?xml version="1.0" encoding="utf-8"?>
-<p:sld xmlns:a="http://schemas.openxmlformats.org/drawingml/2006/main" xmlns:r="http://schemas.openxmlformats.org/officeDocument/2006/relationships" xmlns:p="http://schemas.openxmlformats.org/presentationml/2006/main">
+<p:sld xmlns:a="http://schemas.openxmlformats.org/drawingml/2006/main" xmlns:p="http://schemas.openxmlformats.org/presentationml/2006/main" xmlns:r="http://schemas.openxmlformats.org/officeDocument/2006/relationships">
   <p:cSld>
     <p:bg>
       <p:bgPr>
@@ -3377,14 +3306,7 @@
         <p:cNvGrpSpPr/>
         <p:nvPr/>
       </p:nvGrpSpPr>
-      <p:grpSpPr>
-        <a:xfrm>
-          <a:off x="0" y="0"/>
-          <a:ext cx="0" cy="0"/>
-          <a:chOff x="0" y="0"/>
-          <a:chExt cx="0" cy="0"/>
-        </a:xfrm>
-      </p:grpSpPr>
+      <p:grpSpPr/>
       <p:sp>
         <p:nvSpPr>
           <p:cNvPr id="2" name="Rectangle 1"/>
@@ -3425,7 +3347,6 @@
           <a:lstStyle/>
           <a:p>
             <a:pPr algn="ctr"/>
-            <a:endParaRPr/>
           </a:p>
         </p:txBody>
       </p:sp>
@@ -3503,7 +3424,6 @@
           <a:lstStyle/>
           <a:p>
             <a:pPr algn="ctr"/>
-            <a:endParaRPr/>
           </a:p>
         </p:txBody>
       </p:sp>
@@ -3664,7 +3584,6 @@
           <a:lstStyle/>
           <a:p>
             <a:pPr algn="ctr"/>
-            <a:endParaRPr/>
           </a:p>
         </p:txBody>
       </p:sp>
@@ -3742,7 +3661,6 @@
           <a:lstStyle/>
           <a:p>
             <a:pPr algn="ctr"/>
-            <a:endParaRPr/>
           </a:p>
         </p:txBody>
       </p:sp>
@@ -3855,7 +3773,6 @@
           <a:lstStyle/>
           <a:p>
             <a:pPr algn="ctr"/>
-            <a:endParaRPr/>
           </a:p>
         </p:txBody>
       </p:sp>
@@ -3968,7 +3885,6 @@
           <a:lstStyle/>
           <a:p>
             <a:pPr algn="ctr"/>
-            <a:endParaRPr/>
           </a:p>
         </p:txBody>
       </p:sp>
@@ -4050,7 +3966,7 @@
 </file>
 
 <file path=ppt/slides/slide3.xml><?xml version="1.0" encoding="utf-8"?>
-<p:sld xmlns:a="http://schemas.openxmlformats.org/drawingml/2006/main" xmlns:r="http://schemas.openxmlformats.org/officeDocument/2006/relationships" xmlns:p="http://schemas.openxmlformats.org/presentationml/2006/main">
+<p:sld xmlns:a="http://schemas.openxmlformats.org/drawingml/2006/main" xmlns:p="http://schemas.openxmlformats.org/presentationml/2006/main" xmlns:r="http://schemas.openxmlformats.org/officeDocument/2006/relationships">
   <p:cSld>
     <p:bg>
       <p:bgPr>
@@ -4066,14 +3982,7 @@
         <p:cNvGrpSpPr/>
         <p:nvPr/>
       </p:nvGrpSpPr>
-      <p:grpSpPr>
-        <a:xfrm>
-          <a:off x="0" y="0"/>
-          <a:ext cx="0" cy="0"/>
-          <a:chOff x="0" y="0"/>
-          <a:chExt cx="0" cy="0"/>
-        </a:xfrm>
-      </p:grpSpPr>
+      <p:grpSpPr/>
       <p:sp>
         <p:nvSpPr>
           <p:cNvPr id="2" name="Rectangle 1"/>
@@ -4114,7 +4023,6 @@
           <a:lstStyle/>
           <a:p>
             <a:pPr algn="ctr"/>
-            <a:endParaRPr/>
           </a:p>
         </p:txBody>
       </p:sp>
@@ -4192,7 +4100,6 @@
           <a:lstStyle/>
           <a:p>
             <a:pPr algn="ctr"/>
-            <a:endParaRPr/>
           </a:p>
         </p:txBody>
       </p:sp>
@@ -4270,7 +4177,6 @@
           <a:lstStyle/>
           <a:p>
             <a:pPr algn="ctr"/>
-            <a:endParaRPr/>
           </a:p>
         </p:txBody>
       </p:sp>
@@ -4384,7 +4290,6 @@
           <a:lstStyle/>
           <a:p>
             <a:pPr algn="ctr"/>
-            <a:endParaRPr/>
           </a:p>
         </p:txBody>
       </p:sp>
@@ -4498,7 +4403,6 @@
           <a:lstStyle/>
           <a:p>
             <a:pPr algn="ctr"/>
-            <a:endParaRPr/>
           </a:p>
         </p:txBody>
       </p:sp>
@@ -4615,7 +4519,7 @@
 </file>
 
 <file path=ppt/slides/slide4.xml><?xml version="1.0" encoding="utf-8"?>
-<p:sld xmlns:a="http://schemas.openxmlformats.org/drawingml/2006/main" xmlns:r="http://schemas.openxmlformats.org/officeDocument/2006/relationships" xmlns:p="http://schemas.openxmlformats.org/presentationml/2006/main">
+<p:sld xmlns:a="http://schemas.openxmlformats.org/drawingml/2006/main" xmlns:p="http://schemas.openxmlformats.org/presentationml/2006/main" xmlns:r="http://schemas.openxmlformats.org/officeDocument/2006/relationships">
   <p:cSld>
     <p:bg>
       <p:bgPr>
@@ -4631,14 +4535,7 @@
         <p:cNvGrpSpPr/>
         <p:nvPr/>
       </p:nvGrpSpPr>
-      <p:grpSpPr>
-        <a:xfrm>
-          <a:off x="0" y="0"/>
-          <a:ext cx="0" cy="0"/>
-          <a:chOff x="0" y="0"/>
-          <a:chExt cx="0" cy="0"/>
-        </a:xfrm>
-      </p:grpSpPr>
+      <p:grpSpPr/>
       <p:sp>
         <p:nvSpPr>
           <p:cNvPr id="2" name="Rectangle 1"/>
@@ -4679,7 +4576,6 @@
           <a:lstStyle/>
           <a:p>
             <a:pPr algn="ctr"/>
-            <a:endParaRPr/>
           </a:p>
         </p:txBody>
       </p:sp>
@@ -4757,7 +4653,6 @@
           <a:lstStyle/>
           <a:p>
             <a:pPr algn="ctr"/>
-            <a:endParaRPr/>
           </a:p>
         </p:txBody>
       </p:sp>
@@ -4839,7 +4734,7 @@
         </p:nvSpPr>
         <p:spPr>
           <a:xfrm>
-            <a:off x="2258568" y="1737360"/>
+            <a:off x="2331720" y="1737360"/>
             <a:ext cx="411480" cy="548640"/>
           </a:xfrm>
           <a:prstGeom prst="rect">
@@ -4855,7 +4750,7 @@
           <a:p>
             <a:pPr algn="ctr"/>
             <a:r>
-              <a:rPr sz="2200" b="1" dirty="0">
+              <a:rPr sz="2200" b="1">
                 <a:solidFill>
                   <a:srgbClr val="ED7D31"/>
                 </a:solidFill>
@@ -4905,7 +4800,6 @@
           <a:lstStyle/>
           <a:p>
             <a:pPr algn="ctr"/>
-            <a:endParaRPr/>
           </a:p>
         </p:txBody>
       </p:sp>
@@ -4986,7 +4880,7 @@
         </p:nvSpPr>
         <p:spPr>
           <a:xfrm>
-            <a:off x="4617720" y="1737360"/>
+            <a:off x="4690872" y="1737360"/>
             <a:ext cx="411480" cy="548640"/>
           </a:xfrm>
           <a:prstGeom prst="rect">
@@ -5052,7 +4946,6 @@
           <a:lstStyle/>
           <a:p>
             <a:pPr algn="ctr"/>
-            <a:endParaRPr/>
           </a:p>
         </p:txBody>
       </p:sp>
@@ -5133,7 +5026,7 @@
         </p:nvSpPr>
         <p:spPr>
           <a:xfrm>
-            <a:off x="6976872" y="1737360"/>
+            <a:off x="7050024" y="1737360"/>
             <a:ext cx="411480" cy="548640"/>
           </a:xfrm>
           <a:prstGeom prst="rect">
@@ -5199,7 +5092,6 @@
           <a:lstStyle/>
           <a:p>
             <a:pPr algn="ctr"/>
-            <a:endParaRPr/>
           </a:p>
         </p:txBody>
       </p:sp>
@@ -5281,7 +5173,7 @@
         </p:nvSpPr>
         <p:spPr>
           <a:xfrm>
-            <a:off x="9336024" y="1737360"/>
+            <a:off x="9409176" y="1737360"/>
             <a:ext cx="411480" cy="548640"/>
           </a:xfrm>
           <a:prstGeom prst="rect">
@@ -5347,7 +5239,6 @@
           <a:lstStyle/>
           <a:p>
             <a:pPr algn="ctr"/>
-            <a:endParaRPr/>
           </a:p>
         </p:txBody>
       </p:sp>
@@ -5495,7 +5386,6 @@
           <a:lstStyle/>
           <a:p>
             <a:pPr algn="ctr"/>
-            <a:endParaRPr/>
           </a:p>
         </p:txBody>
       </p:sp>
@@ -5607,7 +5497,6 @@
           <a:lstStyle/>
           <a:p>
             <a:pPr algn="ctr"/>
-            <a:endParaRPr/>
           </a:p>
         </p:txBody>
       </p:sp>
@@ -5719,7 +5608,6 @@
           <a:lstStyle/>
           <a:p>
             <a:pPr algn="ctr"/>
-            <a:endParaRPr/>
           </a:p>
         </p:txBody>
       </p:sp>
@@ -5917,7 +5805,7 @@
 </file>
 
 <file path=ppt/slides/slide5.xml><?xml version="1.0" encoding="utf-8"?>
-<p:sld xmlns:a="http://schemas.openxmlformats.org/drawingml/2006/main" xmlns:r="http://schemas.openxmlformats.org/officeDocument/2006/relationships" xmlns:p="http://schemas.openxmlformats.org/presentationml/2006/main">
+<p:sld xmlns:a="http://schemas.openxmlformats.org/drawingml/2006/main" xmlns:p="http://schemas.openxmlformats.org/presentationml/2006/main" xmlns:r="http://schemas.openxmlformats.org/officeDocument/2006/relationships">
   <p:cSld>
     <p:bg>
       <p:bgPr>
@@ -5933,14 +5821,7 @@
         <p:cNvGrpSpPr/>
         <p:nvPr/>
       </p:nvGrpSpPr>
-      <p:grpSpPr>
-        <a:xfrm>
-          <a:off x="0" y="0"/>
-          <a:ext cx="0" cy="0"/>
-          <a:chOff x="0" y="0"/>
-          <a:chExt cx="0" cy="0"/>
-        </a:xfrm>
-      </p:grpSpPr>
+      <p:grpSpPr/>
       <p:sp>
         <p:nvSpPr>
           <p:cNvPr id="2" name="Rectangle 1"/>
@@ -5981,7 +5862,6 @@
           <a:lstStyle/>
           <a:p>
             <a:pPr algn="ctr"/>
-            <a:endParaRPr/>
           </a:p>
         </p:txBody>
       </p:sp>
@@ -6059,7 +5939,6 @@
           <a:lstStyle/>
           <a:p>
             <a:pPr algn="ctr"/>
-            <a:endParaRPr/>
           </a:p>
         </p:txBody>
       </p:sp>
@@ -6137,7 +6016,6 @@
           <a:lstStyle/>
           <a:p>
             <a:pPr algn="ctr"/>
-            <a:endParaRPr/>
           </a:p>
         </p:txBody>
       </p:sp>
@@ -6250,7 +6128,6 @@
           <a:lstStyle/>
           <a:p>
             <a:pPr algn="ctr"/>
-            <a:endParaRPr/>
           </a:p>
         </p:txBody>
       </p:sp>
@@ -6328,7 +6205,6 @@
           <a:lstStyle/>
           <a:p>
             <a:pPr algn="ctr"/>
-            <a:endParaRPr/>
           </a:p>
         </p:txBody>
       </p:sp>
@@ -6441,7 +6317,6 @@
           <a:lstStyle/>
           <a:p>
             <a:pPr algn="ctr"/>
-            <a:endParaRPr/>
           </a:p>
         </p:txBody>
       </p:sp>
@@ -6519,7 +6394,6 @@
           <a:lstStyle/>
           <a:p>
             <a:pPr algn="ctr"/>
-            <a:endParaRPr/>
           </a:p>
         </p:txBody>
       </p:sp>
@@ -6632,7 +6506,6 @@
           <a:lstStyle/>
           <a:p>
             <a:pPr algn="ctr"/>
-            <a:endParaRPr/>
           </a:p>
         </p:txBody>
       </p:sp>
@@ -6710,7 +6583,6 @@
           <a:lstStyle/>
           <a:p>
             <a:pPr algn="ctr"/>
-            <a:endParaRPr/>
           </a:p>
         </p:txBody>
       </p:sp>
@@ -6823,7 +6695,6 @@
           <a:lstStyle/>
           <a:p>
             <a:pPr algn="ctr"/>
-            <a:endParaRPr/>
           </a:p>
         </p:txBody>
       </p:sp>
@@ -6953,7 +6824,7 @@
 </file>
 
 <file path=ppt/slides/slide6.xml><?xml version="1.0" encoding="utf-8"?>
-<p:sld xmlns:a="http://schemas.openxmlformats.org/drawingml/2006/main" xmlns:r="http://schemas.openxmlformats.org/officeDocument/2006/relationships" xmlns:p="http://schemas.openxmlformats.org/presentationml/2006/main">
+<p:sld xmlns:a="http://schemas.openxmlformats.org/drawingml/2006/main" xmlns:p="http://schemas.openxmlformats.org/presentationml/2006/main" xmlns:r="http://schemas.openxmlformats.org/officeDocument/2006/relationships">
   <p:cSld>
     <p:bg>
       <p:bgPr>
@@ -6969,14 +6840,7 @@
         <p:cNvGrpSpPr/>
         <p:nvPr/>
       </p:nvGrpSpPr>
-      <p:grpSpPr>
-        <a:xfrm>
-          <a:off x="0" y="0"/>
-          <a:ext cx="0" cy="0"/>
-          <a:chOff x="0" y="0"/>
-          <a:chExt cx="0" cy="0"/>
-        </a:xfrm>
-      </p:grpSpPr>
+      <p:grpSpPr/>
       <p:sp>
         <p:nvSpPr>
           <p:cNvPr id="2" name="Rectangle 1"/>
@@ -7017,7 +6881,6 @@
           <a:lstStyle/>
           <a:p>
             <a:pPr algn="ctr"/>
-            <a:endParaRPr/>
           </a:p>
         </p:txBody>
       </p:sp>
@@ -7095,7 +6958,6 @@
           <a:lstStyle/>
           <a:p>
             <a:pPr algn="ctr"/>
-            <a:endParaRPr/>
           </a:p>
         </p:txBody>
       </p:sp>
@@ -7173,7 +7035,6 @@
           <a:lstStyle/>
           <a:p>
             <a:pPr algn="ctr"/>
-            <a:endParaRPr/>
           </a:p>
         </p:txBody>
       </p:sp>
@@ -7285,7 +7146,6 @@
           <a:lstStyle/>
           <a:p>
             <a:pPr algn="ctr"/>
-            <a:endParaRPr/>
           </a:p>
         </p:txBody>
       </p:sp>
@@ -7363,7 +7223,6 @@
           <a:lstStyle/>
           <a:p>
             <a:pPr algn="ctr"/>
-            <a:endParaRPr/>
           </a:p>
         </p:txBody>
       </p:sp>
@@ -7475,7 +7334,6 @@
           <a:lstStyle/>
           <a:p>
             <a:pPr algn="ctr"/>
-            <a:endParaRPr/>
           </a:p>
         </p:txBody>
       </p:sp>
@@ -7553,7 +7411,6 @@
           <a:lstStyle/>
           <a:p>
             <a:pPr algn="ctr"/>
-            <a:endParaRPr/>
           </a:p>
         </p:txBody>
       </p:sp>
@@ -7665,7 +7522,6 @@
           <a:lstStyle/>
           <a:p>
             <a:pPr algn="ctr"/>
-            <a:endParaRPr/>
           </a:p>
         </p:txBody>
       </p:sp>
@@ -7743,7 +7599,6 @@
           <a:lstStyle/>
           <a:p>
             <a:pPr algn="ctr"/>
-            <a:endParaRPr/>
           </a:p>
         </p:txBody>
       </p:sp>
@@ -7855,7 +7710,6 @@
           <a:lstStyle/>
           <a:p>
             <a:pPr algn="ctr"/>
-            <a:endParaRPr/>
           </a:p>
         </p:txBody>
       </p:sp>
@@ -8050,7 +7904,6 @@
           <a:lstStyle/>
           <a:p>
             <a:pPr algn="ctr"/>
-            <a:endParaRPr/>
           </a:p>
         </p:txBody>
       </p:sp>
@@ -8128,7 +7981,6 @@
           <a:lstStyle/>
           <a:p>
             <a:pPr algn="ctr"/>
-            <a:endParaRPr/>
           </a:p>
         </p:txBody>
       </p:sp>
@@ -8206,7 +8058,6 @@
           <a:lstStyle/>
           <a:p>
             <a:pPr algn="ctr"/>
-            <a:endParaRPr/>
           </a:p>
         </p:txBody>
       </p:sp>
@@ -8284,7 +8135,6 @@
           <a:lstStyle/>
           <a:p>
             <a:pPr algn="ctr"/>
-            <a:endParaRPr/>
           </a:p>
         </p:txBody>
       </p:sp>
@@ -8362,7 +8212,6 @@
           <a:lstStyle/>
           <a:p>
             <a:pPr algn="ctr"/>
-            <a:endParaRPr/>
           </a:p>
         </p:txBody>
       </p:sp>
@@ -8726,10 +8575,4 @@
   </a:objectDefaults>
   <a:extraClrSchemeLst/>
 </a:theme>
-</file>
-
-<file path=docMetadata/LabelInfo.xml><?xml version="1.0" encoding="utf-8"?>
-<clbl:labelList xmlns:clbl="http://schemas.microsoft.com/office/2020/mipLabelMetadata">
-  <clbl:label id="{2f9fb377-9e61-415d-9daf-610bc4ecb38b}" enabled="0" method="" siteId="{2f9fb377-9e61-415d-9daf-610bc4ecb38b}" removed="1"/>
-</clbl:labelList>
 </file>
</xml_diff>

<commit_message>
Lisa dashboard tulemuste slaidid (slaid 7-8) PDF-ist
Co-Authored-By: Claude Sonnet 4.6 <noreply@anthropic.com>
</commit_message>
<xml_diff>
--- a/docs/esitlus.pptx
+++ b/docs/esitlus.pptx
@@ -11,6 +11,8 @@
     <p:sldId id="259" r:id="rId5"/>
     <p:sldId id="260" r:id="rId6"/>
     <p:sldId id="261" r:id="rId7"/>
+    <p:sldId id="262" r:id="rId13"/>
+    <p:sldId id="263" r:id="rId14"/>
   </p:sldIdLst>
   <p:sldSz cx="12188825" cy="6858000"/>
   <p:notesSz cx="6858000" cy="9144000"/>
@@ -3360,6 +3362,920 @@
 </p:sld>
 </file>
 
+<file path=ppt/slides/slide10.xml><?xml version="1.0" encoding="utf-8"?>
+<p:sld xmlns:a="http://schemas.openxmlformats.org/drawingml/2006/main" xmlns:p="http://schemas.openxmlformats.org/presentationml/2006/main" xmlns:r="http://schemas.openxmlformats.org/officeDocument/2006/relationships">
+  <p:cSld>
+    <p:bg>
+      <p:bgPr>
+        <a:solidFill>
+          <a:srgbClr val="FFFFFF"/>
+        </a:solidFill>
+        <a:effectLst/>
+      </p:bgPr>
+    </p:bg>
+    <p:spTree>
+      <p:nvGrpSpPr>
+        <p:cNvPr id="1" name=""/>
+        <p:cNvGrpSpPr/>
+        <p:nvPr/>
+      </p:nvGrpSpPr>
+      <p:grpSpPr/>
+      <p:sp>
+        <p:nvSpPr>
+          <p:cNvPr id="2" name="Rectangle 1"/>
+          <p:cNvSpPr/>
+          <p:nvPr/>
+        </p:nvSpPr>
+        <p:spPr>
+          <a:xfrm>
+            <a:off x="0" y="0"/>
+            <a:ext cx="12188952" cy="1005840"/>
+          </a:xfrm>
+          <a:prstGeom prst="rect">
+            <a:avLst/>
+          </a:prstGeom>
+          <a:solidFill>
+            <a:srgbClr val="1B376B"/>
+          </a:solidFill>
+          <a:ln>
+            <a:noFill/>
+          </a:ln>
+        </p:spPr>
+        <p:style>
+          <a:lnRef idx="1">
+            <a:schemeClr val="accent1"/>
+          </a:lnRef>
+          <a:fillRef idx="3">
+            <a:schemeClr val="accent1"/>
+          </a:fillRef>
+          <a:effectRef idx="2">
+            <a:schemeClr val="accent1"/>
+          </a:effectRef>
+          <a:fontRef idx="minor">
+            <a:schemeClr val="lt1"/>
+          </a:fontRef>
+        </p:style>
+        <p:txBody>
+          <a:bodyPr rtlCol="0" anchor="ctr"/>
+          <a:lstStyle/>
+          <a:p>
+            <a:pPr algn="ctr"/>
+          </a:p>
+        </p:txBody>
+      </p:sp>
+      <p:sp>
+        <p:nvSpPr>
+          <p:cNvPr id="3" name="TextBox 2"/>
+          <p:cNvSpPr txBox="1"/>
+          <p:nvPr/>
+        </p:nvSpPr>
+        <p:spPr>
+          <a:xfrm>
+            <a:off x="365760" y="91440"/>
+            <a:ext cx="11430000" cy="777240"/>
+          </a:xfrm>
+          <a:prstGeom prst="rect">
+            <a:avLst/>
+          </a:prstGeom>
+          <a:noFill/>
+        </p:spPr>
+        <p:txBody>
+          <a:bodyPr wrap="square">
+            <a:spAutoFit/>
+          </a:bodyPr>
+          <a:lstStyle/>
+          <a:p>
+            <a:pPr algn="l"/>
+            <a:r>
+              <a:rPr sz="2800" b="1">
+                <a:solidFill>
+                  <a:srgbClr val="FFFFFF"/>
+                </a:solidFill>
+              </a:rPr>
+              <a:t>Järeldused ja ärimeetrikud</a:t>
+            </a:r>
+          </a:p>
+        </p:txBody>
+      </p:sp>
+      <p:sp>
+        <p:nvSpPr>
+          <p:cNvPr id="4" name="Rectangle 3"/>
+          <p:cNvSpPr/>
+          <p:nvPr/>
+        </p:nvSpPr>
+        <p:spPr>
+          <a:xfrm>
+            <a:off x="274320" y="1143000"/>
+            <a:ext cx="7132320" cy="4343400"/>
+          </a:xfrm>
+          <a:prstGeom prst="rect">
+            <a:avLst/>
+          </a:prstGeom>
+          <a:solidFill>
+            <a:srgbClr val="F2F2F2"/>
+          </a:solidFill>
+          <a:ln>
+            <a:noFill/>
+          </a:ln>
+        </p:spPr>
+        <p:style>
+          <a:lnRef idx="1">
+            <a:schemeClr val="accent1"/>
+          </a:lnRef>
+          <a:fillRef idx="3">
+            <a:schemeClr val="accent1"/>
+          </a:fillRef>
+          <a:effectRef idx="2">
+            <a:schemeClr val="accent1"/>
+          </a:effectRef>
+          <a:fontRef idx="minor">
+            <a:schemeClr val="lt1"/>
+          </a:fontRef>
+        </p:style>
+        <p:txBody>
+          <a:bodyPr rtlCol="0" anchor="ctr"/>
+          <a:lstStyle/>
+          <a:p>
+            <a:pPr algn="ctr"/>
+          </a:p>
+        </p:txBody>
+      </p:sp>
+      <p:sp>
+        <p:nvSpPr>
+          <p:cNvPr id="5" name="TextBox 4"/>
+          <p:cNvSpPr txBox="1"/>
+          <p:nvPr/>
+        </p:nvSpPr>
+        <p:spPr>
+          <a:xfrm>
+            <a:off x="457200" y="1207008"/>
+            <a:ext cx="6766560" cy="457200"/>
+          </a:xfrm>
+          <a:prstGeom prst="rect">
+            <a:avLst/>
+          </a:prstGeom>
+          <a:noFill/>
+        </p:spPr>
+        <p:txBody>
+          <a:bodyPr wrap="square">
+            <a:spAutoFit/>
+          </a:bodyPr>
+          <a:lstStyle/>
+          <a:p>
+            <a:pPr algn="l"/>
+            <a:r>
+              <a:rPr sz="1600" b="1">
+                <a:solidFill>
+                  <a:srgbClr val="1B376B"/>
+                </a:solidFill>
+              </a:rPr>
+              <a:t>Peamised järeldused</a:t>
+            </a:r>
+          </a:p>
+        </p:txBody>
+      </p:sp>
+      <p:sp>
+        <p:nvSpPr>
+          <p:cNvPr id="6" name="TextBox 5"/>
+          <p:cNvSpPr txBox="1"/>
+          <p:nvPr/>
+        </p:nvSpPr>
+        <p:spPr>
+          <a:xfrm>
+            <a:off x="457200" y="1737360"/>
+            <a:ext cx="6858000" cy="3566160"/>
+          </a:xfrm>
+          <a:prstGeom prst="rect">
+            <a:avLst/>
+          </a:prstGeom>
+          <a:noFill/>
+        </p:spPr>
+        <p:txBody>
+          <a:bodyPr wrap="square">
+            <a:spAutoFit/>
+          </a:bodyPr>
+          <a:lstStyle/>
+          <a:p>
+            <a:pPr>
+              <a:spcBef>
+                <a:spcPts val="300"/>
+              </a:spcBef>
+            </a:pPr>
+            <a:r>
+              <a:rPr sz="1400">
+                <a:solidFill>
+                  <a:srgbClr val="404040"/>
+                </a:solidFill>
+              </a:rPr>
+              <a:t>•  Finantsiliselt tasuvam: Kambja vald (ROI 3.4) ja Saue vald (ROI 3.36)</a:t>
+            </a:r>
+          </a:p>
+          <a:p>
+            <a:pPr>
+              <a:spcBef>
+                <a:spcPts val="300"/>
+              </a:spcBef>
+            </a:pPr>
+            <a:r>
+              <a:rPr sz="1400">
+                <a:solidFill>
+                  <a:srgbClr val="404040"/>
+                </a:solidFill>
+              </a:rPr>
+              <a:t>•  Suurim absoluutne säästupotentsiaal: Tallinn (üle 100M €/aastas)</a:t>
+            </a:r>
+          </a:p>
+          <a:p>
+            <a:pPr>
+              <a:spcBef>
+                <a:spcPts val="300"/>
+              </a:spcBef>
+            </a:pPr>
+            <a:r>
+              <a:rPr sz="1400">
+                <a:solidFill>
+                  <a:srgbClr val="404040"/>
+                </a:solidFill>
+              </a:rPr>
+              <a:t>•  Vajaduspõhiselt haavatavaimad: Lääneranna, Kihnu ja Räpina vald</a:t>
+            </a:r>
+          </a:p>
+          <a:p>
+            <a:pPr>
+              <a:spcBef>
+                <a:spcPts val="300"/>
+              </a:spcBef>
+            </a:pPr>
+            <a:r>
+              <a:rPr sz="1400">
+                <a:solidFill>
+                  <a:srgbClr val="404040"/>
+                </a:solidFill>
+              </a:rPr>
+              <a:t>•  Tallinna ja Tartu linna ROI on madalam (2.26–2.27), aga kogu mõju suurim</a:t>
+            </a:r>
+          </a:p>
+          <a:p>
+            <a:pPr>
+              <a:spcBef>
+                <a:spcPts val="300"/>
+              </a:spcBef>
+            </a:pPr>
+            <a:r>
+              <a:rPr sz="1400">
+                <a:solidFill>
+                  <a:srgbClr val="404040"/>
+                </a:solidFill>
+              </a:rPr>
+              <a:t>•  Kokkuvõte: kõrge ROI → väiksemad vallad; suur säästusumma → linnad</a:t>
+            </a:r>
+          </a:p>
+        </p:txBody>
+      </p:sp>
+      <p:sp>
+        <p:nvSpPr>
+          <p:cNvPr id="7" name="Rectangle 6"/>
+          <p:cNvSpPr/>
+          <p:nvPr/>
+        </p:nvSpPr>
+        <p:spPr>
+          <a:xfrm>
+            <a:off x="7680960" y="1143000"/>
+            <a:ext cx="4206240" cy="4343400"/>
+          </a:xfrm>
+          <a:prstGeom prst="rect">
+            <a:avLst/>
+          </a:prstGeom>
+          <a:solidFill>
+            <a:srgbClr val="1B376B"/>
+          </a:solidFill>
+          <a:ln>
+            <a:noFill/>
+          </a:ln>
+        </p:spPr>
+        <p:style>
+          <a:lnRef idx="1">
+            <a:schemeClr val="accent1"/>
+          </a:lnRef>
+          <a:fillRef idx="3">
+            <a:schemeClr val="accent1"/>
+          </a:fillRef>
+          <a:effectRef idx="2">
+            <a:schemeClr val="accent1"/>
+          </a:effectRef>
+          <a:fontRef idx="minor">
+            <a:schemeClr val="lt1"/>
+          </a:fontRef>
+        </p:style>
+        <p:txBody>
+          <a:bodyPr rtlCol="0" anchor="ctr"/>
+          <a:lstStyle/>
+          <a:p>
+            <a:pPr algn="ctr"/>
+          </a:p>
+        </p:txBody>
+      </p:sp>
+      <p:sp>
+        <p:nvSpPr>
+          <p:cNvPr id="8" name="TextBox 7"/>
+          <p:cNvSpPr txBox="1"/>
+          <p:nvPr/>
+        </p:nvSpPr>
+        <p:spPr>
+          <a:xfrm>
+            <a:off x="7818120" y="1207008"/>
+            <a:ext cx="3931920" cy="457200"/>
+          </a:xfrm>
+          <a:prstGeom prst="rect">
+            <a:avLst/>
+          </a:prstGeom>
+          <a:noFill/>
+        </p:spPr>
+        <p:txBody>
+          <a:bodyPr wrap="square">
+            <a:spAutoFit/>
+          </a:bodyPr>
+          <a:lstStyle/>
+          <a:p>
+            <a:pPr algn="l"/>
+            <a:r>
+              <a:rPr sz="1400" b="1">
+                <a:solidFill>
+                  <a:srgbClr val="FFFFFF"/>
+                </a:solidFill>
+              </a:rPr>
+              <a:t>Ärimeetrikute valemid</a:t>
+            </a:r>
+          </a:p>
+        </p:txBody>
+      </p:sp>
+      <p:sp>
+        <p:nvSpPr>
+          <p:cNvPr id="9" name="Rectangle 8"/>
+          <p:cNvSpPr/>
+          <p:nvPr/>
+        </p:nvSpPr>
+        <p:spPr>
+          <a:xfrm>
+            <a:off x="7726679" y="1783080"/>
+            <a:ext cx="4069080" cy="749808"/>
+          </a:xfrm>
+          <a:prstGeom prst="rect">
+            <a:avLst/>
+          </a:prstGeom>
+          <a:solidFill>
+            <a:srgbClr val="2E75B6"/>
+          </a:solidFill>
+          <a:ln>
+            <a:noFill/>
+          </a:ln>
+        </p:spPr>
+        <p:style>
+          <a:lnRef idx="1">
+            <a:schemeClr val="accent1"/>
+          </a:lnRef>
+          <a:fillRef idx="3">
+            <a:schemeClr val="accent1"/>
+          </a:fillRef>
+          <a:effectRef idx="2">
+            <a:schemeClr val="accent1"/>
+          </a:effectRef>
+          <a:fontRef idx="minor">
+            <a:schemeClr val="lt1"/>
+          </a:fontRef>
+        </p:style>
+        <p:txBody>
+          <a:bodyPr rtlCol="0" anchor="ctr"/>
+          <a:lstStyle/>
+          <a:p>
+            <a:pPr algn="ctr"/>
+          </a:p>
+        </p:txBody>
+      </p:sp>
+      <p:sp>
+        <p:nvSpPr>
+          <p:cNvPr id="10" name="TextBox 9"/>
+          <p:cNvSpPr txBox="1"/>
+          <p:nvPr/>
+        </p:nvSpPr>
+        <p:spPr>
+          <a:xfrm>
+            <a:off x="7836408" y="1801368"/>
+            <a:ext cx="3840480" cy="320040"/>
+          </a:xfrm>
+          <a:prstGeom prst="rect">
+            <a:avLst/>
+          </a:prstGeom>
+          <a:noFill/>
+        </p:spPr>
+        <p:txBody>
+          <a:bodyPr wrap="square">
+            <a:spAutoFit/>
+          </a:bodyPr>
+          <a:lstStyle/>
+          <a:p>
+            <a:pPr algn="l"/>
+            <a:r>
+              <a:rPr sz="1100" b="1">
+                <a:solidFill>
+                  <a:srgbClr val="FFFFFF"/>
+                </a:solidFill>
+              </a:rPr>
+              <a:t>ROI</a:t>
+            </a:r>
+          </a:p>
+        </p:txBody>
+      </p:sp>
+      <p:sp>
+        <p:nvSpPr>
+          <p:cNvPr id="11" name="TextBox 10"/>
+          <p:cNvSpPr txBox="1"/>
+          <p:nvPr/>
+        </p:nvSpPr>
+        <p:spPr>
+          <a:xfrm>
+            <a:off x="7836408" y="2130552"/>
+            <a:ext cx="3840480" cy="384048"/>
+          </a:xfrm>
+          <a:prstGeom prst="rect">
+            <a:avLst/>
+          </a:prstGeom>
+          <a:noFill/>
+        </p:spPr>
+        <p:txBody>
+          <a:bodyPr wrap="square">
+            <a:spAutoFit/>
+          </a:bodyPr>
+          <a:lstStyle/>
+          <a:p>
+            <a:pPr algn="l"/>
+            <a:r>
+              <a:rPr sz="1000" b="0">
+                <a:solidFill>
+                  <a:srgbClr val="BDD7EE"/>
+                </a:solidFill>
+              </a:rPr>
+              <a:t>sääst_eur_aastas
+/ investeering</a:t>
+            </a:r>
+          </a:p>
+        </p:txBody>
+      </p:sp>
+      <p:sp>
+        <p:nvSpPr>
+          <p:cNvPr id="12" name="Rectangle 11"/>
+          <p:cNvSpPr/>
+          <p:nvPr/>
+        </p:nvSpPr>
+        <p:spPr>
+          <a:xfrm>
+            <a:off x="7726679" y="2606040"/>
+            <a:ext cx="4069080" cy="749808"/>
+          </a:xfrm>
+          <a:prstGeom prst="rect">
+            <a:avLst/>
+          </a:prstGeom>
+          <a:solidFill>
+            <a:srgbClr val="2E75B6"/>
+          </a:solidFill>
+          <a:ln>
+            <a:noFill/>
+          </a:ln>
+        </p:spPr>
+        <p:style>
+          <a:lnRef idx="1">
+            <a:schemeClr val="accent1"/>
+          </a:lnRef>
+          <a:fillRef idx="3">
+            <a:schemeClr val="accent1"/>
+          </a:fillRef>
+          <a:effectRef idx="2">
+            <a:schemeClr val="accent1"/>
+          </a:effectRef>
+          <a:fontRef idx="minor">
+            <a:schemeClr val="lt1"/>
+          </a:fontRef>
+        </p:style>
+        <p:txBody>
+          <a:bodyPr rtlCol="0" anchor="ctr"/>
+          <a:lstStyle/>
+          <a:p>
+            <a:pPr algn="ctr"/>
+          </a:p>
+        </p:txBody>
+      </p:sp>
+      <p:sp>
+        <p:nvSpPr>
+          <p:cNvPr id="13" name="TextBox 12"/>
+          <p:cNvSpPr txBox="1"/>
+          <p:nvPr/>
+        </p:nvSpPr>
+        <p:spPr>
+          <a:xfrm>
+            <a:off x="7836408" y="2624328"/>
+            <a:ext cx="3840480" cy="320040"/>
+          </a:xfrm>
+          <a:prstGeom prst="rect">
+            <a:avLst/>
+          </a:prstGeom>
+          <a:noFill/>
+        </p:spPr>
+        <p:txBody>
+          <a:bodyPr wrap="square">
+            <a:spAutoFit/>
+          </a:bodyPr>
+          <a:lstStyle/>
+          <a:p>
+            <a:pPr algn="l"/>
+            <a:r>
+              <a:rPr sz="1100" b="1">
+                <a:solidFill>
+                  <a:srgbClr val="FFFFFF"/>
+                </a:solidFill>
+              </a:rPr>
+              <a:t>VAJADUSE SKOOR</a:t>
+            </a:r>
+          </a:p>
+        </p:txBody>
+      </p:sp>
+      <p:sp>
+        <p:nvSpPr>
+          <p:cNvPr id="14" name="TextBox 13"/>
+          <p:cNvSpPr txBox="1"/>
+          <p:nvPr/>
+        </p:nvSpPr>
+        <p:spPr>
+          <a:xfrm>
+            <a:off x="7836408" y="2953512"/>
+            <a:ext cx="3840480" cy="384048"/>
+          </a:xfrm>
+          <a:prstGeom prst="rect">
+            <a:avLst/>
+          </a:prstGeom>
+          <a:noFill/>
+        </p:spPr>
+        <p:txBody>
+          <a:bodyPr wrap="square">
+            <a:spAutoFit/>
+          </a:bodyPr>
+          <a:lstStyle/>
+          <a:p>
+            <a:pPr algn="l"/>
+            <a:r>
+              <a:rPr sz="1000" b="0">
+                <a:solidFill>
+                  <a:srgbClr val="BDD7EE"/>
+                </a:solidFill>
+              </a:rPr>
+              <a:t>soojakadu_kwh
+/ kogupindala_m²</a:t>
+            </a:r>
+          </a:p>
+        </p:txBody>
+      </p:sp>
+      <p:sp>
+        <p:nvSpPr>
+          <p:cNvPr id="15" name="Rectangle 14"/>
+          <p:cNvSpPr/>
+          <p:nvPr/>
+        </p:nvSpPr>
+        <p:spPr>
+          <a:xfrm>
+            <a:off x="7726679" y="3429000"/>
+            <a:ext cx="4069080" cy="749808"/>
+          </a:xfrm>
+          <a:prstGeom prst="rect">
+            <a:avLst/>
+          </a:prstGeom>
+          <a:solidFill>
+            <a:srgbClr val="2E75B6"/>
+          </a:solidFill>
+          <a:ln>
+            <a:noFill/>
+          </a:ln>
+        </p:spPr>
+        <p:style>
+          <a:lnRef idx="1">
+            <a:schemeClr val="accent1"/>
+          </a:lnRef>
+          <a:fillRef idx="3">
+            <a:schemeClr val="accent1"/>
+          </a:fillRef>
+          <a:effectRef idx="2">
+            <a:schemeClr val="accent1"/>
+          </a:effectRef>
+          <a:fontRef idx="minor">
+            <a:schemeClr val="lt1"/>
+          </a:fontRef>
+        </p:style>
+        <p:txBody>
+          <a:bodyPr rtlCol="0" anchor="ctr"/>
+          <a:lstStyle/>
+          <a:p>
+            <a:pPr algn="ctr"/>
+          </a:p>
+        </p:txBody>
+      </p:sp>
+      <p:sp>
+        <p:nvSpPr>
+          <p:cNvPr id="16" name="TextBox 15"/>
+          <p:cNvSpPr txBox="1"/>
+          <p:nvPr/>
+        </p:nvSpPr>
+        <p:spPr>
+          <a:xfrm>
+            <a:off x="7836408" y="3447288"/>
+            <a:ext cx="3840480" cy="320040"/>
+          </a:xfrm>
+          <a:prstGeom prst="rect">
+            <a:avLst/>
+          </a:prstGeom>
+          <a:noFill/>
+        </p:spPr>
+        <p:txBody>
+          <a:bodyPr wrap="square">
+            <a:spAutoFit/>
+          </a:bodyPr>
+          <a:lstStyle/>
+          <a:p>
+            <a:pPr algn="l"/>
+            <a:r>
+              <a:rPr sz="1100" b="1">
+                <a:solidFill>
+                  <a:srgbClr val="FFFFFF"/>
+                </a:solidFill>
+              </a:rPr>
+              <a:t>INVESTEERING</a:t>
+            </a:r>
+          </a:p>
+        </p:txBody>
+      </p:sp>
+      <p:sp>
+        <p:nvSpPr>
+          <p:cNvPr id="17" name="TextBox 16"/>
+          <p:cNvSpPr txBox="1"/>
+          <p:nvPr/>
+        </p:nvSpPr>
+        <p:spPr>
+          <a:xfrm>
+            <a:off x="7836408" y="3776472"/>
+            <a:ext cx="3840480" cy="384048"/>
+          </a:xfrm>
+          <a:prstGeom prst="rect">
+            <a:avLst/>
+          </a:prstGeom>
+          <a:noFill/>
+        </p:spPr>
+        <p:txBody>
+          <a:bodyPr wrap="square">
+            <a:spAutoFit/>
+          </a:bodyPr>
+          <a:lstStyle/>
+          <a:p>
+            <a:pPr algn="l"/>
+            <a:r>
+              <a:rPr sz="1000" b="0">
+                <a:solidFill>
+                  <a:srgbClr val="BDD7EE"/>
+                </a:solidFill>
+              </a:rPr>
+              <a:t>kogupindala_m² × 250
+(€/m² proxy)</a:t>
+            </a:r>
+          </a:p>
+        </p:txBody>
+      </p:sp>
+      <p:sp>
+        <p:nvSpPr>
+          <p:cNvPr id="18" name="Rectangle 17"/>
+          <p:cNvSpPr/>
+          <p:nvPr/>
+        </p:nvSpPr>
+        <p:spPr>
+          <a:xfrm>
+            <a:off x="7726679" y="4251960"/>
+            <a:ext cx="4069080" cy="749808"/>
+          </a:xfrm>
+          <a:prstGeom prst="rect">
+            <a:avLst/>
+          </a:prstGeom>
+          <a:solidFill>
+            <a:srgbClr val="2E75B6"/>
+          </a:solidFill>
+          <a:ln>
+            <a:noFill/>
+          </a:ln>
+        </p:spPr>
+        <p:style>
+          <a:lnRef idx="1">
+            <a:schemeClr val="accent1"/>
+          </a:lnRef>
+          <a:fillRef idx="3">
+            <a:schemeClr val="accent1"/>
+          </a:fillRef>
+          <a:effectRef idx="2">
+            <a:schemeClr val="accent1"/>
+          </a:effectRef>
+          <a:fontRef idx="minor">
+            <a:schemeClr val="lt1"/>
+          </a:fontRef>
+        </p:style>
+        <p:txBody>
+          <a:bodyPr rtlCol="0" anchor="ctr"/>
+          <a:lstStyle/>
+          <a:p>
+            <a:pPr algn="ctr"/>
+          </a:p>
+        </p:txBody>
+      </p:sp>
+      <p:sp>
+        <p:nvSpPr>
+          <p:cNvPr id="19" name="TextBox 18"/>
+          <p:cNvSpPr txBox="1"/>
+          <p:nvPr/>
+        </p:nvSpPr>
+        <p:spPr>
+          <a:xfrm>
+            <a:off x="7836408" y="4270248"/>
+            <a:ext cx="3840480" cy="320040"/>
+          </a:xfrm>
+          <a:prstGeom prst="rect">
+            <a:avLst/>
+          </a:prstGeom>
+          <a:noFill/>
+        </p:spPr>
+        <p:txBody>
+          <a:bodyPr wrap="square">
+            <a:spAutoFit/>
+          </a:bodyPr>
+          <a:lstStyle/>
+          <a:p>
+            <a:pPr algn="l"/>
+            <a:r>
+              <a:rPr sz="1100" b="1">
+                <a:solidFill>
+                  <a:srgbClr val="FFFFFF"/>
+                </a:solidFill>
+              </a:rPr>
+              <a:t>PRIORITY</a:t>
+            </a:r>
+          </a:p>
+        </p:txBody>
+      </p:sp>
+      <p:sp>
+        <p:nvSpPr>
+          <p:cNvPr id="20" name="TextBox 19"/>
+          <p:cNvSpPr txBox="1"/>
+          <p:nvPr/>
+        </p:nvSpPr>
+        <p:spPr>
+          <a:xfrm>
+            <a:off x="7836408" y="4599432"/>
+            <a:ext cx="3840480" cy="384048"/>
+          </a:xfrm>
+          <a:prstGeom prst="rect">
+            <a:avLst/>
+          </a:prstGeom>
+          <a:noFill/>
+        </p:spPr>
+        <p:txBody>
+          <a:bodyPr wrap="square">
+            <a:spAutoFit/>
+          </a:bodyPr>
+          <a:lstStyle/>
+          <a:p>
+            <a:pPr algn="l"/>
+            <a:r>
+              <a:rPr sz="1000" b="0">
+                <a:solidFill>
+                  <a:srgbClr val="BDD7EE"/>
+                </a:solidFill>
+              </a:rPr>
+              <a:t>LOG(sääst+1) × LOG(skoor+1)
+× LOG(pindala+1)</a:t>
+            </a:r>
+          </a:p>
+        </p:txBody>
+      </p:sp>
+      <p:sp>
+        <p:nvSpPr>
+          <p:cNvPr id="21" name="Rectangle 20"/>
+          <p:cNvSpPr/>
+          <p:nvPr/>
+        </p:nvSpPr>
+        <p:spPr>
+          <a:xfrm>
+            <a:off x="7726679" y="5074920"/>
+            <a:ext cx="4069080" cy="749808"/>
+          </a:xfrm>
+          <a:prstGeom prst="rect">
+            <a:avLst/>
+          </a:prstGeom>
+          <a:solidFill>
+            <a:srgbClr val="2E75B6"/>
+          </a:solidFill>
+          <a:ln>
+            <a:noFill/>
+          </a:ln>
+        </p:spPr>
+        <p:style>
+          <a:lnRef idx="1">
+            <a:schemeClr val="accent1"/>
+          </a:lnRef>
+          <a:fillRef idx="3">
+            <a:schemeClr val="accent1"/>
+          </a:fillRef>
+          <a:effectRef idx="2">
+            <a:schemeClr val="accent1"/>
+          </a:effectRef>
+          <a:fontRef idx="minor">
+            <a:schemeClr val="lt1"/>
+          </a:fontRef>
+        </p:style>
+        <p:txBody>
+          <a:bodyPr rtlCol="0" anchor="ctr"/>
+          <a:lstStyle/>
+          <a:p>
+            <a:pPr algn="ctr"/>
+          </a:p>
+        </p:txBody>
+      </p:sp>
+      <p:sp>
+        <p:nvSpPr>
+          <p:cNvPr id="22" name="TextBox 21"/>
+          <p:cNvSpPr txBox="1"/>
+          <p:nvPr/>
+        </p:nvSpPr>
+        <p:spPr>
+          <a:xfrm>
+            <a:off x="7836408" y="5093208"/>
+            <a:ext cx="3840480" cy="320040"/>
+          </a:xfrm>
+          <a:prstGeom prst="rect">
+            <a:avLst/>
+          </a:prstGeom>
+          <a:noFill/>
+        </p:spPr>
+        <p:txBody>
+          <a:bodyPr wrap="square">
+            <a:spAutoFit/>
+          </a:bodyPr>
+          <a:lstStyle/>
+          <a:p>
+            <a:pPr algn="l"/>
+            <a:r>
+              <a:rPr sz="1100" b="1">
+                <a:solidFill>
+                  <a:srgbClr val="FFFFFF"/>
+                </a:solidFill>
+              </a:rPr>
+              <a:t>TASUVUS</a:t>
+            </a:r>
+          </a:p>
+        </p:txBody>
+      </p:sp>
+      <p:sp>
+        <p:nvSpPr>
+          <p:cNvPr id="23" name="TextBox 22"/>
+          <p:cNvSpPr txBox="1"/>
+          <p:nvPr/>
+        </p:nvSpPr>
+        <p:spPr>
+          <a:xfrm>
+            <a:off x="7836408" y="5422392"/>
+            <a:ext cx="3840480" cy="384048"/>
+          </a:xfrm>
+          <a:prstGeom prst="rect">
+            <a:avLst/>
+          </a:prstGeom>
+          <a:noFill/>
+        </p:spPr>
+        <p:txBody>
+          <a:bodyPr wrap="square">
+            <a:spAutoFit/>
+          </a:bodyPr>
+          <a:lstStyle/>
+          <a:p>
+            <a:pPr algn="l"/>
+            <a:r>
+              <a:rPr sz="1000" b="0">
+                <a:solidFill>
+                  <a:srgbClr val="BDD7EE"/>
+                </a:solidFill>
+              </a:rPr>
+              <a:t>1 / NULLIF(roi, 0)</a:t>
+            </a:r>
+          </a:p>
+        </p:txBody>
+      </p:sp>
+    </p:spTree>
+  </p:cSld>
+  <p:clrMapOvr>
+    <a:masterClrMapping/>
+  </p:clrMapOvr>
+</p:sld>
+</file>
+
 <file path=ppt/slides/slide2.xml><?xml version="1.0" encoding="utf-8"?>
 <p:sld xmlns:a="http://schemas.openxmlformats.org/drawingml/2006/main" xmlns:r="http://schemas.openxmlformats.org/officeDocument/2006/relationships" xmlns:p="http://schemas.openxmlformats.org/presentationml/2006/main">
   <p:cSld>
@@ -8396,6 +9312,2686 @@
                 </a:solidFill>
               </a:rPr>
               <a:t>Docker</a:t>
+            </a:r>
+          </a:p>
+        </p:txBody>
+      </p:sp>
+    </p:spTree>
+  </p:cSld>
+  <p:clrMapOvr>
+    <a:masterClrMapping/>
+  </p:clrMapOvr>
+</p:sld>
+</file>
+
+<file path=ppt/slides/slide7.xml><?xml version="1.0" encoding="utf-8"?>
+<p:sld xmlns:a="http://schemas.openxmlformats.org/drawingml/2006/main" xmlns:p="http://schemas.openxmlformats.org/presentationml/2006/main" xmlns:r="http://schemas.openxmlformats.org/officeDocument/2006/relationships">
+  <p:cSld>
+    <p:bg>
+      <p:bgPr>
+        <a:solidFill>
+          <a:srgbClr val="FFFFFF"/>
+        </a:solidFill>
+        <a:effectLst/>
+      </p:bgPr>
+    </p:bg>
+    <p:spTree>
+      <p:nvGrpSpPr>
+        <p:cNvPr id="1" name=""/>
+        <p:cNvGrpSpPr/>
+        <p:nvPr/>
+      </p:nvGrpSpPr>
+      <p:grpSpPr/>
+      <p:sp>
+        <p:nvSpPr>
+          <p:cNvPr id="2" name="Rectangle 1"/>
+          <p:cNvSpPr/>
+          <p:nvPr/>
+        </p:nvSpPr>
+        <p:spPr>
+          <a:xfrm>
+            <a:off x="0" y="0"/>
+            <a:ext cx="12188952" cy="1005840"/>
+          </a:xfrm>
+          <a:prstGeom prst="rect">
+            <a:avLst/>
+          </a:prstGeom>
+          <a:solidFill>
+            <a:srgbClr val="1B376B"/>
+          </a:solidFill>
+          <a:ln>
+            <a:noFill/>
+          </a:ln>
+        </p:spPr>
+        <p:style>
+          <a:lnRef idx="1">
+            <a:schemeClr val="accent1"/>
+          </a:lnRef>
+          <a:fillRef idx="3">
+            <a:schemeClr val="accent1"/>
+          </a:fillRef>
+          <a:effectRef idx="2">
+            <a:schemeClr val="accent1"/>
+          </a:effectRef>
+          <a:fontRef idx="minor">
+            <a:schemeClr val="lt1"/>
+          </a:fontRef>
+        </p:style>
+        <p:txBody>
+          <a:bodyPr rtlCol="0" anchor="ctr"/>
+          <a:lstStyle/>
+          <a:p>
+            <a:pPr algn="ctr"/>
+          </a:p>
+        </p:txBody>
+      </p:sp>
+      <p:sp>
+        <p:nvSpPr>
+          <p:cNvPr id="3" name="TextBox 2"/>
+          <p:cNvSpPr txBox="1"/>
+          <p:nvPr/>
+        </p:nvSpPr>
+        <p:spPr>
+          <a:xfrm>
+            <a:off x="365760" y="91440"/>
+            <a:ext cx="11430000" cy="777240"/>
+          </a:xfrm>
+          <a:prstGeom prst="rect">
+            <a:avLst/>
+          </a:prstGeom>
+          <a:noFill/>
+        </p:spPr>
+        <p:txBody>
+          <a:bodyPr wrap="square">
+            <a:spAutoFit/>
+          </a:bodyPr>
+          <a:lstStyle/>
+          <a:p>
+            <a:pPr algn="l"/>
+            <a:r>
+              <a:rPr sz="2800" b="1">
+                <a:solidFill>
+                  <a:srgbClr val="FFFFFF"/>
+                </a:solidFill>
+              </a:rPr>
+              <a:t>Dashboard: põhitulemused</a:t>
+            </a:r>
+          </a:p>
+        </p:txBody>
+      </p:sp>
+      <p:sp>
+        <p:nvSpPr>
+          <p:cNvPr id="4" name="Rectangle 3"/>
+          <p:cNvSpPr/>
+          <p:nvPr/>
+        </p:nvSpPr>
+        <p:spPr>
+          <a:xfrm>
+            <a:off x="274320" y="1143000"/>
+            <a:ext cx="2697480" cy="1371600"/>
+          </a:xfrm>
+          <a:prstGeom prst="rect">
+            <a:avLst/>
+          </a:prstGeom>
+          <a:solidFill>
+            <a:srgbClr val="1B376B"/>
+          </a:solidFill>
+          <a:ln>
+            <a:noFill/>
+          </a:ln>
+        </p:spPr>
+        <p:style>
+          <a:lnRef idx="1">
+            <a:schemeClr val="accent1"/>
+          </a:lnRef>
+          <a:fillRef idx="3">
+            <a:schemeClr val="accent1"/>
+          </a:fillRef>
+          <a:effectRef idx="2">
+            <a:schemeClr val="accent1"/>
+          </a:effectRef>
+          <a:fontRef idx="minor">
+            <a:schemeClr val="lt1"/>
+          </a:fontRef>
+        </p:style>
+        <p:txBody>
+          <a:bodyPr rtlCol="0" anchor="ctr"/>
+          <a:lstStyle/>
+          <a:p>
+            <a:pPr algn="ctr"/>
+          </a:p>
+        </p:txBody>
+      </p:sp>
+      <p:sp>
+        <p:nvSpPr>
+          <p:cNvPr id="5" name="TextBox 4"/>
+          <p:cNvSpPr txBox="1"/>
+          <p:nvPr/>
+        </p:nvSpPr>
+        <p:spPr>
+          <a:xfrm>
+            <a:off x="365760" y="1188720"/>
+            <a:ext cx="2514600" cy="502920"/>
+          </a:xfrm>
+          <a:prstGeom prst="rect">
+            <a:avLst/>
+          </a:prstGeom>
+          <a:noFill/>
+        </p:spPr>
+        <p:txBody>
+          <a:bodyPr wrap="square">
+            <a:spAutoFit/>
+          </a:bodyPr>
+          <a:lstStyle/>
+          <a:p>
+            <a:pPr algn="ctr"/>
+            <a:r>
+              <a:rPr sz="1300" b="0">
+                <a:solidFill>
+                  <a:srgbClr val="FFFFFF"/>
+                </a:solidFill>
+              </a:rPr>
+              <a:t>Soojakadu Eestis</a:t>
+            </a:r>
+          </a:p>
+        </p:txBody>
+      </p:sp>
+      <p:sp>
+        <p:nvSpPr>
+          <p:cNvPr id="6" name="TextBox 5"/>
+          <p:cNvSpPr txBox="1"/>
+          <p:nvPr/>
+        </p:nvSpPr>
+        <p:spPr>
+          <a:xfrm>
+            <a:off x="320040" y="1691640"/>
+            <a:ext cx="2606040" cy="685800"/>
+          </a:xfrm>
+          <a:prstGeom prst="rect">
+            <a:avLst/>
+          </a:prstGeom>
+          <a:noFill/>
+        </p:spPr>
+        <p:txBody>
+          <a:bodyPr wrap="square">
+            <a:spAutoFit/>
+          </a:bodyPr>
+          <a:lstStyle/>
+          <a:p>
+            <a:pPr algn="ctr"/>
+            <a:r>
+              <a:rPr sz="2200" b="1">
+                <a:solidFill>
+                  <a:srgbClr val="FFFFFF"/>
+                </a:solidFill>
+              </a:rPr>
+              <a:t>9.26B kWh</a:t>
+            </a:r>
+          </a:p>
+        </p:txBody>
+      </p:sp>
+      <p:sp>
+        <p:nvSpPr>
+          <p:cNvPr id="7" name="Rectangle 6"/>
+          <p:cNvSpPr/>
+          <p:nvPr/>
+        </p:nvSpPr>
+        <p:spPr>
+          <a:xfrm>
+            <a:off x="3182112" y="1143000"/>
+            <a:ext cx="2697480" cy="1371600"/>
+          </a:xfrm>
+          <a:prstGeom prst="rect">
+            <a:avLst/>
+          </a:prstGeom>
+          <a:solidFill>
+            <a:srgbClr val="2E75B6"/>
+          </a:solidFill>
+          <a:ln>
+            <a:noFill/>
+          </a:ln>
+        </p:spPr>
+        <p:style>
+          <a:lnRef idx="1">
+            <a:schemeClr val="accent1"/>
+          </a:lnRef>
+          <a:fillRef idx="3">
+            <a:schemeClr val="accent1"/>
+          </a:fillRef>
+          <a:effectRef idx="2">
+            <a:schemeClr val="accent1"/>
+          </a:effectRef>
+          <a:fontRef idx="minor">
+            <a:schemeClr val="lt1"/>
+          </a:fontRef>
+        </p:style>
+        <p:txBody>
+          <a:bodyPr rtlCol="0" anchor="ctr"/>
+          <a:lstStyle/>
+          <a:p>
+            <a:pPr algn="ctr"/>
+          </a:p>
+        </p:txBody>
+      </p:sp>
+      <p:sp>
+        <p:nvSpPr>
+          <p:cNvPr id="8" name="TextBox 7"/>
+          <p:cNvSpPr txBox="1"/>
+          <p:nvPr/>
+        </p:nvSpPr>
+        <p:spPr>
+          <a:xfrm>
+            <a:off x="3273552" y="1188720"/>
+            <a:ext cx="2514600" cy="502920"/>
+          </a:xfrm>
+          <a:prstGeom prst="rect">
+            <a:avLst/>
+          </a:prstGeom>
+          <a:noFill/>
+        </p:spPr>
+        <p:txBody>
+          <a:bodyPr wrap="square">
+            <a:spAutoFit/>
+          </a:bodyPr>
+          <a:lstStyle/>
+          <a:p>
+            <a:pPr algn="ctr"/>
+            <a:r>
+              <a:rPr sz="1300" b="0">
+                <a:solidFill>
+                  <a:srgbClr val="FFFFFF"/>
+                </a:solidFill>
+              </a:rPr>
+              <a:t>Kulu</a:t>
+            </a:r>
+          </a:p>
+        </p:txBody>
+      </p:sp>
+      <p:sp>
+        <p:nvSpPr>
+          <p:cNvPr id="9" name="TextBox 8"/>
+          <p:cNvSpPr txBox="1"/>
+          <p:nvPr/>
+        </p:nvSpPr>
+        <p:spPr>
+          <a:xfrm>
+            <a:off x="3227832" y="1691640"/>
+            <a:ext cx="2606040" cy="685800"/>
+          </a:xfrm>
+          <a:prstGeom prst="rect">
+            <a:avLst/>
+          </a:prstGeom>
+          <a:noFill/>
+        </p:spPr>
+        <p:txBody>
+          <a:bodyPr wrap="square">
+            <a:spAutoFit/>
+          </a:bodyPr>
+          <a:lstStyle/>
+          <a:p>
+            <a:pPr algn="ctr"/>
+            <a:r>
+              <a:rPr sz="2200" b="1">
+                <a:solidFill>
+                  <a:srgbClr val="FFFFFF"/>
+                </a:solidFill>
+              </a:rPr>
+              <a:t>660M €</a:t>
+            </a:r>
+          </a:p>
+        </p:txBody>
+      </p:sp>
+      <p:sp>
+        <p:nvSpPr>
+          <p:cNvPr id="10" name="Rectangle 9"/>
+          <p:cNvSpPr/>
+          <p:nvPr/>
+        </p:nvSpPr>
+        <p:spPr>
+          <a:xfrm>
+            <a:off x="6089904" y="1143000"/>
+            <a:ext cx="2697480" cy="1371600"/>
+          </a:xfrm>
+          <a:prstGeom prst="rect">
+            <a:avLst/>
+          </a:prstGeom>
+          <a:solidFill>
+            <a:srgbClr val="5A9E6F"/>
+          </a:solidFill>
+          <a:ln>
+            <a:noFill/>
+          </a:ln>
+        </p:spPr>
+        <p:style>
+          <a:lnRef idx="1">
+            <a:schemeClr val="accent1"/>
+          </a:lnRef>
+          <a:fillRef idx="3">
+            <a:schemeClr val="accent1"/>
+          </a:fillRef>
+          <a:effectRef idx="2">
+            <a:schemeClr val="accent1"/>
+          </a:effectRef>
+          <a:fontRef idx="minor">
+            <a:schemeClr val="lt1"/>
+          </a:fontRef>
+        </p:style>
+        <p:txBody>
+          <a:bodyPr rtlCol="0" anchor="ctr"/>
+          <a:lstStyle/>
+          <a:p>
+            <a:pPr algn="ctr"/>
+          </a:p>
+        </p:txBody>
+      </p:sp>
+      <p:sp>
+        <p:nvSpPr>
+          <p:cNvPr id="11" name="TextBox 10"/>
+          <p:cNvSpPr txBox="1"/>
+          <p:nvPr/>
+        </p:nvSpPr>
+        <p:spPr>
+          <a:xfrm>
+            <a:off x="6181344" y="1188720"/>
+            <a:ext cx="2514600" cy="502920"/>
+          </a:xfrm>
+          <a:prstGeom prst="rect">
+            <a:avLst/>
+          </a:prstGeom>
+          <a:noFill/>
+        </p:spPr>
+        <p:txBody>
+          <a:bodyPr wrap="square">
+            <a:spAutoFit/>
+          </a:bodyPr>
+          <a:lstStyle/>
+          <a:p>
+            <a:pPr algn="ctr"/>
+            <a:r>
+              <a:rPr sz="1300" b="0">
+                <a:solidFill>
+                  <a:srgbClr val="FFFFFF"/>
+                </a:solidFill>
+              </a:rPr>
+              <a:t>Säästupotentsiaal</a:t>
+            </a:r>
+          </a:p>
+        </p:txBody>
+      </p:sp>
+      <p:sp>
+        <p:nvSpPr>
+          <p:cNvPr id="12" name="TextBox 11"/>
+          <p:cNvSpPr txBox="1"/>
+          <p:nvPr/>
+        </p:nvSpPr>
+        <p:spPr>
+          <a:xfrm>
+            <a:off x="6135624" y="1691640"/>
+            <a:ext cx="2606040" cy="685800"/>
+          </a:xfrm>
+          <a:prstGeom prst="rect">
+            <a:avLst/>
+          </a:prstGeom>
+          <a:noFill/>
+        </p:spPr>
+        <p:txBody>
+          <a:bodyPr wrap="square">
+            <a:spAutoFit/>
+          </a:bodyPr>
+          <a:lstStyle/>
+          <a:p>
+            <a:pPr algn="ctr"/>
+            <a:r>
+              <a:rPr sz="2200" b="1">
+                <a:solidFill>
+                  <a:srgbClr val="FFFFFF"/>
+                </a:solidFill>
+              </a:rPr>
+              <a:t>423M €/aastas</a:t>
+            </a:r>
+          </a:p>
+        </p:txBody>
+      </p:sp>
+      <p:sp>
+        <p:nvSpPr>
+          <p:cNvPr id="13" name="Rectangle 12"/>
+          <p:cNvSpPr/>
+          <p:nvPr/>
+        </p:nvSpPr>
+        <p:spPr>
+          <a:xfrm>
+            <a:off x="8997696" y="1143000"/>
+            <a:ext cx="2697480" cy="1371600"/>
+          </a:xfrm>
+          <a:prstGeom prst="rect">
+            <a:avLst/>
+          </a:prstGeom>
+          <a:solidFill>
+            <a:srgbClr val="ED7D31"/>
+          </a:solidFill>
+          <a:ln>
+            <a:noFill/>
+          </a:ln>
+        </p:spPr>
+        <p:style>
+          <a:lnRef idx="1">
+            <a:schemeClr val="accent1"/>
+          </a:lnRef>
+          <a:fillRef idx="3">
+            <a:schemeClr val="accent1"/>
+          </a:fillRef>
+          <a:effectRef idx="2">
+            <a:schemeClr val="accent1"/>
+          </a:effectRef>
+          <a:fontRef idx="minor">
+            <a:schemeClr val="lt1"/>
+          </a:fontRef>
+        </p:style>
+        <p:txBody>
+          <a:bodyPr rtlCol="0" anchor="ctr"/>
+          <a:lstStyle/>
+          <a:p>
+            <a:pPr algn="ctr"/>
+          </a:p>
+        </p:txBody>
+      </p:sp>
+      <p:sp>
+        <p:nvSpPr>
+          <p:cNvPr id="14" name="TextBox 13"/>
+          <p:cNvSpPr txBox="1"/>
+          <p:nvPr/>
+        </p:nvSpPr>
+        <p:spPr>
+          <a:xfrm>
+            <a:off x="9089136" y="1188720"/>
+            <a:ext cx="2514600" cy="502920"/>
+          </a:xfrm>
+          <a:prstGeom prst="rect">
+            <a:avLst/>
+          </a:prstGeom>
+          <a:noFill/>
+        </p:spPr>
+        <p:txBody>
+          <a:bodyPr wrap="square">
+            <a:spAutoFit/>
+          </a:bodyPr>
+          <a:lstStyle/>
+          <a:p>
+            <a:pPr algn="ctr"/>
+            <a:r>
+              <a:rPr sz="1300" b="0">
+                <a:solidFill>
+                  <a:srgbClr val="FFFFFF"/>
+                </a:solidFill>
+              </a:rPr>
+              <a:t>Keskmine intensiivsus</a:t>
+            </a:r>
+          </a:p>
+        </p:txBody>
+      </p:sp>
+      <p:sp>
+        <p:nvSpPr>
+          <p:cNvPr id="15" name="TextBox 14"/>
+          <p:cNvSpPr txBox="1"/>
+          <p:nvPr/>
+        </p:nvSpPr>
+        <p:spPr>
+          <a:xfrm>
+            <a:off x="9043416" y="1691640"/>
+            <a:ext cx="2606040" cy="685800"/>
+          </a:xfrm>
+          <a:prstGeom prst="rect">
+            <a:avLst/>
+          </a:prstGeom>
+          <a:noFill/>
+        </p:spPr>
+        <p:txBody>
+          <a:bodyPr wrap="square">
+            <a:spAutoFit/>
+          </a:bodyPr>
+          <a:lstStyle/>
+          <a:p>
+            <a:pPr algn="ctr"/>
+            <a:r>
+              <a:rPr sz="2200" b="1">
+                <a:solidFill>
+                  <a:srgbClr val="FFFFFF"/>
+                </a:solidFill>
+              </a:rPr>
+              <a:t>149.93 kWh/m²</a:t>
+            </a:r>
+          </a:p>
+        </p:txBody>
+      </p:sp>
+      <p:sp>
+        <p:nvSpPr>
+          <p:cNvPr id="16" name="Rectangle 15"/>
+          <p:cNvSpPr/>
+          <p:nvPr/>
+        </p:nvSpPr>
+        <p:spPr>
+          <a:xfrm>
+            <a:off x="274320" y="2743200"/>
+            <a:ext cx="3794760" cy="3474720"/>
+          </a:xfrm>
+          <a:prstGeom prst="rect">
+            <a:avLst/>
+          </a:prstGeom>
+          <a:solidFill>
+            <a:srgbClr val="F2F2F2"/>
+          </a:solidFill>
+          <a:ln>
+            <a:noFill/>
+          </a:ln>
+        </p:spPr>
+        <p:style>
+          <a:lnRef idx="1">
+            <a:schemeClr val="accent1"/>
+          </a:lnRef>
+          <a:fillRef idx="3">
+            <a:schemeClr val="accent1"/>
+          </a:fillRef>
+          <a:effectRef idx="2">
+            <a:schemeClr val="accent1"/>
+          </a:effectRef>
+          <a:fontRef idx="minor">
+            <a:schemeClr val="lt1"/>
+          </a:fontRef>
+        </p:style>
+        <p:txBody>
+          <a:bodyPr rtlCol="0" anchor="ctr"/>
+          <a:lstStyle/>
+          <a:p>
+            <a:pPr algn="ctr"/>
+          </a:p>
+        </p:txBody>
+      </p:sp>
+      <p:sp>
+        <p:nvSpPr>
+          <p:cNvPr id="17" name="TextBox 16"/>
+          <p:cNvSpPr txBox="1"/>
+          <p:nvPr/>
+        </p:nvSpPr>
+        <p:spPr>
+          <a:xfrm>
+            <a:off x="384048" y="2807208"/>
+            <a:ext cx="3566160" cy="594360"/>
+          </a:xfrm>
+          <a:prstGeom prst="rect">
+            <a:avLst/>
+          </a:prstGeom>
+          <a:noFill/>
+        </p:spPr>
+        <p:txBody>
+          <a:bodyPr wrap="square">
+            <a:spAutoFit/>
+          </a:bodyPr>
+          <a:lstStyle/>
+          <a:p>
+            <a:pPr algn="l"/>
+            <a:r>
+              <a:rPr sz="1200" b="1">
+                <a:solidFill>
+                  <a:srgbClr val="2E75B6"/>
+                </a:solidFill>
+              </a:rPr>
+              <a:t>Suurim vajadus renoveerimiseks (vajaduse skoor)</a:t>
+            </a:r>
+          </a:p>
+        </p:txBody>
+      </p:sp>
+      <p:sp>
+        <p:nvSpPr>
+          <p:cNvPr id="18" name="TextBox 17"/>
+          <p:cNvSpPr txBox="1"/>
+          <p:nvPr/>
+        </p:nvSpPr>
+        <p:spPr>
+          <a:xfrm>
+            <a:off x="384048" y="3429000"/>
+            <a:ext cx="3566160" cy="2651760"/>
+          </a:xfrm>
+          <a:prstGeom prst="rect">
+            <a:avLst/>
+          </a:prstGeom>
+          <a:noFill/>
+        </p:spPr>
+        <p:txBody>
+          <a:bodyPr wrap="square">
+            <a:spAutoFit/>
+          </a:bodyPr>
+          <a:lstStyle/>
+          <a:p>
+            <a:pPr algn="l"/>
+            <a:r>
+              <a:rPr sz="1200" b="0">
+                <a:solidFill>
+                  <a:srgbClr val="404040"/>
+                </a:solidFill>
+              </a:rPr>
+              <a:t>Lääneranna vald · Kihnu vald · Räpina vald · Toila vald · Kanepi vald
+Mõõdik: soojakadu_kwh_aastas / kogupindala_m²</a:t>
+            </a:r>
+          </a:p>
+        </p:txBody>
+      </p:sp>
+      <p:sp>
+        <p:nvSpPr>
+          <p:cNvPr id="19" name="Rectangle 18"/>
+          <p:cNvSpPr/>
+          <p:nvPr/>
+        </p:nvSpPr>
+        <p:spPr>
+          <a:xfrm>
+            <a:off x="4251959" y="2743200"/>
+            <a:ext cx="3794760" cy="3474720"/>
+          </a:xfrm>
+          <a:prstGeom prst="rect">
+            <a:avLst/>
+          </a:prstGeom>
+          <a:solidFill>
+            <a:srgbClr val="F2F2F2"/>
+          </a:solidFill>
+          <a:ln>
+            <a:noFill/>
+          </a:ln>
+        </p:spPr>
+        <p:style>
+          <a:lnRef idx="1">
+            <a:schemeClr val="accent1"/>
+          </a:lnRef>
+          <a:fillRef idx="3">
+            <a:schemeClr val="accent1"/>
+          </a:fillRef>
+          <a:effectRef idx="2">
+            <a:schemeClr val="accent1"/>
+          </a:effectRef>
+          <a:fontRef idx="minor">
+            <a:schemeClr val="lt1"/>
+          </a:fontRef>
+        </p:style>
+        <p:txBody>
+          <a:bodyPr rtlCol="0" anchor="ctr"/>
+          <a:lstStyle/>
+          <a:p>
+            <a:pPr algn="ctr"/>
+          </a:p>
+        </p:txBody>
+      </p:sp>
+      <p:sp>
+        <p:nvSpPr>
+          <p:cNvPr id="20" name="TextBox 19"/>
+          <p:cNvSpPr txBox="1"/>
+          <p:nvPr/>
+        </p:nvSpPr>
+        <p:spPr>
+          <a:xfrm>
+            <a:off x="4361688" y="2807208"/>
+            <a:ext cx="3566160" cy="594360"/>
+          </a:xfrm>
+          <a:prstGeom prst="rect">
+            <a:avLst/>
+          </a:prstGeom>
+          <a:noFill/>
+        </p:spPr>
+        <p:txBody>
+          <a:bodyPr wrap="square">
+            <a:spAutoFit/>
+          </a:bodyPr>
+          <a:lstStyle/>
+          <a:p>
+            <a:pPr algn="l"/>
+            <a:r>
+              <a:rPr sz="1200" b="1">
+                <a:solidFill>
+                  <a:srgbClr val="2E75B6"/>
+                </a:solidFill>
+              </a:rPr>
+              <a:t>TOP 10 KOV — suurim aastane säästupotentsiaal (€)</a:t>
+            </a:r>
+          </a:p>
+        </p:txBody>
+      </p:sp>
+      <p:sp>
+        <p:nvSpPr>
+          <p:cNvPr id="21" name="TextBox 20"/>
+          <p:cNvSpPr txBox="1"/>
+          <p:nvPr/>
+        </p:nvSpPr>
+        <p:spPr>
+          <a:xfrm>
+            <a:off x="4361688" y="3429000"/>
+            <a:ext cx="3566160" cy="2651760"/>
+          </a:xfrm>
+          <a:prstGeom prst="rect">
+            <a:avLst/>
+          </a:prstGeom>
+          <a:noFill/>
+        </p:spPr>
+        <p:txBody>
+          <a:bodyPr wrap="square">
+            <a:spAutoFit/>
+          </a:bodyPr>
+          <a:lstStyle/>
+          <a:p>
+            <a:pPr algn="l"/>
+            <a:r>
+              <a:rPr sz="1200" b="0">
+                <a:solidFill>
+                  <a:srgbClr val="404040"/>
+                </a:solidFill>
+              </a:rPr>
+              <a:t>Tallinn ~100M € · Tartu linn ~20M € · Pärnu linn · Narva linn
+Kohtla-Järve · Saaremaa vald · Viljandi vald · Jõgeva vald · Elva vald</a:t>
+            </a:r>
+          </a:p>
+        </p:txBody>
+      </p:sp>
+      <p:sp>
+        <p:nvSpPr>
+          <p:cNvPr id="22" name="Rectangle 21"/>
+          <p:cNvSpPr/>
+          <p:nvPr/>
+        </p:nvSpPr>
+        <p:spPr>
+          <a:xfrm>
+            <a:off x="8229600" y="2743200"/>
+            <a:ext cx="3794760" cy="3474720"/>
+          </a:xfrm>
+          <a:prstGeom prst="rect">
+            <a:avLst/>
+          </a:prstGeom>
+          <a:solidFill>
+            <a:srgbClr val="F2F2F2"/>
+          </a:solidFill>
+          <a:ln>
+            <a:noFill/>
+          </a:ln>
+        </p:spPr>
+        <p:style>
+          <a:lnRef idx="1">
+            <a:schemeClr val="accent1"/>
+          </a:lnRef>
+          <a:fillRef idx="3">
+            <a:schemeClr val="accent1"/>
+          </a:fillRef>
+          <a:effectRef idx="2">
+            <a:schemeClr val="accent1"/>
+          </a:effectRef>
+          <a:fontRef idx="minor">
+            <a:schemeClr val="lt1"/>
+          </a:fontRef>
+        </p:style>
+        <p:txBody>
+          <a:bodyPr rtlCol="0" anchor="ctr"/>
+          <a:lstStyle/>
+          <a:p>
+            <a:pPr algn="ctr"/>
+          </a:p>
+        </p:txBody>
+      </p:sp>
+      <p:sp>
+        <p:nvSpPr>
+          <p:cNvPr id="23" name="TextBox 22"/>
+          <p:cNvSpPr txBox="1"/>
+          <p:nvPr/>
+        </p:nvSpPr>
+        <p:spPr>
+          <a:xfrm>
+            <a:off x="8339327" y="2807208"/>
+            <a:ext cx="3566160" cy="594360"/>
+          </a:xfrm>
+          <a:prstGeom prst="rect">
+            <a:avLst/>
+          </a:prstGeom>
+          <a:noFill/>
+        </p:spPr>
+        <p:txBody>
+          <a:bodyPr wrap="square">
+            <a:spAutoFit/>
+          </a:bodyPr>
+          <a:lstStyle/>
+          <a:p>
+            <a:pPr algn="l"/>
+            <a:r>
+              <a:rPr sz="1200" b="1">
+                <a:solidFill>
+                  <a:srgbClr val="2E75B6"/>
+                </a:solidFill>
+              </a:rPr>
+              <a:t>Investeeringu tasuvus — ROI vs tasuvusaeg</a:t>
+            </a:r>
+          </a:p>
+        </p:txBody>
+      </p:sp>
+      <p:sp>
+        <p:nvSpPr>
+          <p:cNvPr id="24" name="TextBox 23"/>
+          <p:cNvSpPr txBox="1"/>
+          <p:nvPr/>
+        </p:nvSpPr>
+        <p:spPr>
+          <a:xfrm>
+            <a:off x="8339327" y="3429000"/>
+            <a:ext cx="3566160" cy="2651760"/>
+          </a:xfrm>
+          <a:prstGeom prst="rect">
+            <a:avLst/>
+          </a:prstGeom>
+          <a:noFill/>
+        </p:spPr>
+        <p:txBody>
+          <a:bodyPr wrap="square">
+            <a:spAutoFit/>
+          </a:bodyPr>
+          <a:lstStyle/>
+          <a:p>
+            <a:pPr algn="l"/>
+            <a:r>
+              <a:rPr sz="1200" b="0">
+                <a:solidFill>
+                  <a:srgbClr val="404040"/>
+                </a:solidFill>
+              </a:rPr>
+              <a:t>Kambja vald (ROI 3.4) · Saue vald (3.36) · Tori vald (3.31)
+Rapla vald (3.21) — finantsiliselt kõige tasuvam renoveerimine</a:t>
+            </a:r>
+          </a:p>
+        </p:txBody>
+      </p:sp>
+    </p:spTree>
+  </p:cSld>
+  <p:clrMapOvr>
+    <a:masterClrMapping/>
+  </p:clrMapOvr>
+</p:sld>
+</file>
+
+<file path=ppt/slides/slide8.xml><?xml version="1.0" encoding="utf-8"?>
+<p:sld xmlns:a="http://schemas.openxmlformats.org/drawingml/2006/main" xmlns:p="http://schemas.openxmlformats.org/presentationml/2006/main" xmlns:r="http://schemas.openxmlformats.org/officeDocument/2006/relationships">
+  <p:cSld>
+    <p:bg>
+      <p:bgPr>
+        <a:solidFill>
+          <a:srgbClr val="FFFFFF"/>
+        </a:solidFill>
+        <a:effectLst/>
+      </p:bgPr>
+    </p:bg>
+    <p:spTree>
+      <p:nvGrpSpPr>
+        <p:cNvPr id="1" name=""/>
+        <p:cNvGrpSpPr/>
+        <p:nvPr/>
+      </p:nvGrpSpPr>
+      <p:grpSpPr/>
+      <p:sp>
+        <p:nvSpPr>
+          <p:cNvPr id="2" name="Rectangle 1"/>
+          <p:cNvSpPr/>
+          <p:nvPr/>
+        </p:nvSpPr>
+        <p:spPr>
+          <a:xfrm>
+            <a:off x="0" y="0"/>
+            <a:ext cx="12188952" cy="1005840"/>
+          </a:xfrm>
+          <a:prstGeom prst="rect">
+            <a:avLst/>
+          </a:prstGeom>
+          <a:solidFill>
+            <a:srgbClr val="1B376B"/>
+          </a:solidFill>
+          <a:ln>
+            <a:noFill/>
+          </a:ln>
+        </p:spPr>
+        <p:style>
+          <a:lnRef idx="1">
+            <a:schemeClr val="accent1"/>
+          </a:lnRef>
+          <a:fillRef idx="3">
+            <a:schemeClr val="accent1"/>
+          </a:fillRef>
+          <a:effectRef idx="2">
+            <a:schemeClr val="accent1"/>
+          </a:effectRef>
+          <a:fontRef idx="minor">
+            <a:schemeClr val="lt1"/>
+          </a:fontRef>
+        </p:style>
+        <p:txBody>
+          <a:bodyPr rtlCol="0" anchor="ctr"/>
+          <a:lstStyle/>
+          <a:p>
+            <a:pPr algn="ctr"/>
+          </a:p>
+        </p:txBody>
+      </p:sp>
+      <p:sp>
+        <p:nvSpPr>
+          <p:cNvPr id="3" name="TextBox 2"/>
+          <p:cNvSpPr txBox="1"/>
+          <p:nvPr/>
+        </p:nvSpPr>
+        <p:spPr>
+          <a:xfrm>
+            <a:off x="365760" y="91440"/>
+            <a:ext cx="11430000" cy="777240"/>
+          </a:xfrm>
+          <a:prstGeom prst="rect">
+            <a:avLst/>
+          </a:prstGeom>
+          <a:noFill/>
+        </p:spPr>
+        <p:txBody>
+          <a:bodyPr wrap="square">
+            <a:spAutoFit/>
+          </a:bodyPr>
+          <a:lstStyle/>
+          <a:p>
+            <a:pPr algn="l"/>
+            <a:r>
+              <a:rPr sz="2800" b="1">
+                <a:solidFill>
+                  <a:srgbClr val="FFFFFF"/>
+                </a:solidFill>
+              </a:rPr>
+              <a:t>Järeldused ja ärimeetrikud</a:t>
+            </a:r>
+          </a:p>
+        </p:txBody>
+      </p:sp>
+      <p:sp>
+        <p:nvSpPr>
+          <p:cNvPr id="4" name="Rectangle 3"/>
+          <p:cNvSpPr/>
+          <p:nvPr/>
+        </p:nvSpPr>
+        <p:spPr>
+          <a:xfrm>
+            <a:off x="274320" y="1143000"/>
+            <a:ext cx="7132320" cy="4343400"/>
+          </a:xfrm>
+          <a:prstGeom prst="rect">
+            <a:avLst/>
+          </a:prstGeom>
+          <a:solidFill>
+            <a:srgbClr val="F2F2F2"/>
+          </a:solidFill>
+          <a:ln>
+            <a:noFill/>
+          </a:ln>
+        </p:spPr>
+        <p:style>
+          <a:lnRef idx="1">
+            <a:schemeClr val="accent1"/>
+          </a:lnRef>
+          <a:fillRef idx="3">
+            <a:schemeClr val="accent1"/>
+          </a:fillRef>
+          <a:effectRef idx="2">
+            <a:schemeClr val="accent1"/>
+          </a:effectRef>
+          <a:fontRef idx="minor">
+            <a:schemeClr val="lt1"/>
+          </a:fontRef>
+        </p:style>
+        <p:txBody>
+          <a:bodyPr rtlCol="0" anchor="ctr"/>
+          <a:lstStyle/>
+          <a:p>
+            <a:pPr algn="ctr"/>
+          </a:p>
+        </p:txBody>
+      </p:sp>
+      <p:sp>
+        <p:nvSpPr>
+          <p:cNvPr id="5" name="TextBox 4"/>
+          <p:cNvSpPr txBox="1"/>
+          <p:nvPr/>
+        </p:nvSpPr>
+        <p:spPr>
+          <a:xfrm>
+            <a:off x="457200" y="1207008"/>
+            <a:ext cx="6766560" cy="457200"/>
+          </a:xfrm>
+          <a:prstGeom prst="rect">
+            <a:avLst/>
+          </a:prstGeom>
+          <a:noFill/>
+        </p:spPr>
+        <p:txBody>
+          <a:bodyPr wrap="square">
+            <a:spAutoFit/>
+          </a:bodyPr>
+          <a:lstStyle/>
+          <a:p>
+            <a:pPr algn="l"/>
+            <a:r>
+              <a:rPr sz="1600" b="1">
+                <a:solidFill>
+                  <a:srgbClr val="1B376B"/>
+                </a:solidFill>
+              </a:rPr>
+              <a:t>Peamised järeldused</a:t>
+            </a:r>
+          </a:p>
+        </p:txBody>
+      </p:sp>
+      <p:sp>
+        <p:nvSpPr>
+          <p:cNvPr id="6" name="TextBox 5"/>
+          <p:cNvSpPr txBox="1"/>
+          <p:nvPr/>
+        </p:nvSpPr>
+        <p:spPr>
+          <a:xfrm>
+            <a:off x="457200" y="1737360"/>
+            <a:ext cx="6858000" cy="3566160"/>
+          </a:xfrm>
+          <a:prstGeom prst="rect">
+            <a:avLst/>
+          </a:prstGeom>
+          <a:noFill/>
+        </p:spPr>
+        <p:txBody>
+          <a:bodyPr wrap="square">
+            <a:spAutoFit/>
+          </a:bodyPr>
+          <a:lstStyle/>
+          <a:p>
+            <a:pPr>
+              <a:spcBef>
+                <a:spcPts val="300"/>
+              </a:spcBef>
+            </a:pPr>
+            <a:r>
+              <a:rPr sz="1400">
+                <a:solidFill>
+                  <a:srgbClr val="404040"/>
+                </a:solidFill>
+              </a:rPr>
+              <a:t>•  Finantsiliselt tasuvam: Kambja vald (ROI 3.4) ja Saue vald (ROI 3.36)</a:t>
+            </a:r>
+          </a:p>
+          <a:p>
+            <a:pPr>
+              <a:spcBef>
+                <a:spcPts val="300"/>
+              </a:spcBef>
+            </a:pPr>
+            <a:r>
+              <a:rPr sz="1400">
+                <a:solidFill>
+                  <a:srgbClr val="404040"/>
+                </a:solidFill>
+              </a:rPr>
+              <a:t>•  Suurim absoluutne säästupotentsiaal: Tallinn (üle 100M €/aastas)</a:t>
+            </a:r>
+          </a:p>
+          <a:p>
+            <a:pPr>
+              <a:spcBef>
+                <a:spcPts val="300"/>
+              </a:spcBef>
+            </a:pPr>
+            <a:r>
+              <a:rPr sz="1400">
+                <a:solidFill>
+                  <a:srgbClr val="404040"/>
+                </a:solidFill>
+              </a:rPr>
+              <a:t>•  Vajaduspõhiselt haavatavaimad: Lääneranna, Kihnu ja Räpina vald</a:t>
+            </a:r>
+          </a:p>
+          <a:p>
+            <a:pPr>
+              <a:spcBef>
+                <a:spcPts val="300"/>
+              </a:spcBef>
+            </a:pPr>
+            <a:r>
+              <a:rPr sz="1400">
+                <a:solidFill>
+                  <a:srgbClr val="404040"/>
+                </a:solidFill>
+              </a:rPr>
+              <a:t>•  Tallinna ja Tartu linna ROI on madalam (2.26–2.27), aga kogu mõju suurim</a:t>
+            </a:r>
+          </a:p>
+          <a:p>
+            <a:pPr>
+              <a:spcBef>
+                <a:spcPts val="300"/>
+              </a:spcBef>
+            </a:pPr>
+            <a:r>
+              <a:rPr sz="1400">
+                <a:solidFill>
+                  <a:srgbClr val="404040"/>
+                </a:solidFill>
+              </a:rPr>
+              <a:t>•  Kokkuvõte: kõrge ROI → väiksemad vallad; suur säästusumma → linnad</a:t>
+            </a:r>
+          </a:p>
+        </p:txBody>
+      </p:sp>
+      <p:sp>
+        <p:nvSpPr>
+          <p:cNvPr id="7" name="Rectangle 6"/>
+          <p:cNvSpPr/>
+          <p:nvPr/>
+        </p:nvSpPr>
+        <p:spPr>
+          <a:xfrm>
+            <a:off x="7680960" y="1143000"/>
+            <a:ext cx="4206240" cy="4343400"/>
+          </a:xfrm>
+          <a:prstGeom prst="rect">
+            <a:avLst/>
+          </a:prstGeom>
+          <a:solidFill>
+            <a:srgbClr val="1B376B"/>
+          </a:solidFill>
+          <a:ln>
+            <a:noFill/>
+          </a:ln>
+        </p:spPr>
+        <p:style>
+          <a:lnRef idx="1">
+            <a:schemeClr val="accent1"/>
+          </a:lnRef>
+          <a:fillRef idx="3">
+            <a:schemeClr val="accent1"/>
+          </a:fillRef>
+          <a:effectRef idx="2">
+            <a:schemeClr val="accent1"/>
+          </a:effectRef>
+          <a:fontRef idx="minor">
+            <a:schemeClr val="lt1"/>
+          </a:fontRef>
+        </p:style>
+        <p:txBody>
+          <a:bodyPr rtlCol="0" anchor="ctr"/>
+          <a:lstStyle/>
+          <a:p>
+            <a:pPr algn="ctr"/>
+          </a:p>
+        </p:txBody>
+      </p:sp>
+      <p:sp>
+        <p:nvSpPr>
+          <p:cNvPr id="8" name="TextBox 7"/>
+          <p:cNvSpPr txBox="1"/>
+          <p:nvPr/>
+        </p:nvSpPr>
+        <p:spPr>
+          <a:xfrm>
+            <a:off x="7818120" y="1207008"/>
+            <a:ext cx="3931920" cy="457200"/>
+          </a:xfrm>
+          <a:prstGeom prst="rect">
+            <a:avLst/>
+          </a:prstGeom>
+          <a:noFill/>
+        </p:spPr>
+        <p:txBody>
+          <a:bodyPr wrap="square">
+            <a:spAutoFit/>
+          </a:bodyPr>
+          <a:lstStyle/>
+          <a:p>
+            <a:pPr algn="l"/>
+            <a:r>
+              <a:rPr sz="1400" b="1">
+                <a:solidFill>
+                  <a:srgbClr val="FFFFFF"/>
+                </a:solidFill>
+              </a:rPr>
+              <a:t>Ärimeetrikute valemid</a:t>
+            </a:r>
+          </a:p>
+        </p:txBody>
+      </p:sp>
+      <p:sp>
+        <p:nvSpPr>
+          <p:cNvPr id="9" name="Rectangle 8"/>
+          <p:cNvSpPr/>
+          <p:nvPr/>
+        </p:nvSpPr>
+        <p:spPr>
+          <a:xfrm>
+            <a:off x="7726679" y="1783080"/>
+            <a:ext cx="4069080" cy="749808"/>
+          </a:xfrm>
+          <a:prstGeom prst="rect">
+            <a:avLst/>
+          </a:prstGeom>
+          <a:solidFill>
+            <a:srgbClr val="2E75B6"/>
+          </a:solidFill>
+          <a:ln>
+            <a:noFill/>
+          </a:ln>
+        </p:spPr>
+        <p:style>
+          <a:lnRef idx="1">
+            <a:schemeClr val="accent1"/>
+          </a:lnRef>
+          <a:fillRef idx="3">
+            <a:schemeClr val="accent1"/>
+          </a:fillRef>
+          <a:effectRef idx="2">
+            <a:schemeClr val="accent1"/>
+          </a:effectRef>
+          <a:fontRef idx="minor">
+            <a:schemeClr val="lt1"/>
+          </a:fontRef>
+        </p:style>
+        <p:txBody>
+          <a:bodyPr rtlCol="0" anchor="ctr"/>
+          <a:lstStyle/>
+          <a:p>
+            <a:pPr algn="ctr"/>
+          </a:p>
+        </p:txBody>
+      </p:sp>
+      <p:sp>
+        <p:nvSpPr>
+          <p:cNvPr id="10" name="TextBox 9"/>
+          <p:cNvSpPr txBox="1"/>
+          <p:nvPr/>
+        </p:nvSpPr>
+        <p:spPr>
+          <a:xfrm>
+            <a:off x="7836408" y="1801368"/>
+            <a:ext cx="3840480" cy="320040"/>
+          </a:xfrm>
+          <a:prstGeom prst="rect">
+            <a:avLst/>
+          </a:prstGeom>
+          <a:noFill/>
+        </p:spPr>
+        <p:txBody>
+          <a:bodyPr wrap="square">
+            <a:spAutoFit/>
+          </a:bodyPr>
+          <a:lstStyle/>
+          <a:p>
+            <a:pPr algn="l"/>
+            <a:r>
+              <a:rPr sz="1100" b="1">
+                <a:solidFill>
+                  <a:srgbClr val="FFFFFF"/>
+                </a:solidFill>
+              </a:rPr>
+              <a:t>ROI</a:t>
+            </a:r>
+          </a:p>
+        </p:txBody>
+      </p:sp>
+      <p:sp>
+        <p:nvSpPr>
+          <p:cNvPr id="11" name="TextBox 10"/>
+          <p:cNvSpPr txBox="1"/>
+          <p:nvPr/>
+        </p:nvSpPr>
+        <p:spPr>
+          <a:xfrm>
+            <a:off x="7836408" y="2130552"/>
+            <a:ext cx="3840480" cy="384048"/>
+          </a:xfrm>
+          <a:prstGeom prst="rect">
+            <a:avLst/>
+          </a:prstGeom>
+          <a:noFill/>
+        </p:spPr>
+        <p:txBody>
+          <a:bodyPr wrap="square">
+            <a:spAutoFit/>
+          </a:bodyPr>
+          <a:lstStyle/>
+          <a:p>
+            <a:pPr algn="l"/>
+            <a:r>
+              <a:rPr sz="1000" b="0">
+                <a:solidFill>
+                  <a:srgbClr val="BDD7EE"/>
+                </a:solidFill>
+              </a:rPr>
+              <a:t>sääst_eur_aastas
+/ investeering</a:t>
+            </a:r>
+          </a:p>
+        </p:txBody>
+      </p:sp>
+      <p:sp>
+        <p:nvSpPr>
+          <p:cNvPr id="12" name="Rectangle 11"/>
+          <p:cNvSpPr/>
+          <p:nvPr/>
+        </p:nvSpPr>
+        <p:spPr>
+          <a:xfrm>
+            <a:off x="7726679" y="2606040"/>
+            <a:ext cx="4069080" cy="749808"/>
+          </a:xfrm>
+          <a:prstGeom prst="rect">
+            <a:avLst/>
+          </a:prstGeom>
+          <a:solidFill>
+            <a:srgbClr val="2E75B6"/>
+          </a:solidFill>
+          <a:ln>
+            <a:noFill/>
+          </a:ln>
+        </p:spPr>
+        <p:style>
+          <a:lnRef idx="1">
+            <a:schemeClr val="accent1"/>
+          </a:lnRef>
+          <a:fillRef idx="3">
+            <a:schemeClr val="accent1"/>
+          </a:fillRef>
+          <a:effectRef idx="2">
+            <a:schemeClr val="accent1"/>
+          </a:effectRef>
+          <a:fontRef idx="minor">
+            <a:schemeClr val="lt1"/>
+          </a:fontRef>
+        </p:style>
+        <p:txBody>
+          <a:bodyPr rtlCol="0" anchor="ctr"/>
+          <a:lstStyle/>
+          <a:p>
+            <a:pPr algn="ctr"/>
+          </a:p>
+        </p:txBody>
+      </p:sp>
+      <p:sp>
+        <p:nvSpPr>
+          <p:cNvPr id="13" name="TextBox 12"/>
+          <p:cNvSpPr txBox="1"/>
+          <p:nvPr/>
+        </p:nvSpPr>
+        <p:spPr>
+          <a:xfrm>
+            <a:off x="7836408" y="2624328"/>
+            <a:ext cx="3840480" cy="320040"/>
+          </a:xfrm>
+          <a:prstGeom prst="rect">
+            <a:avLst/>
+          </a:prstGeom>
+          <a:noFill/>
+        </p:spPr>
+        <p:txBody>
+          <a:bodyPr wrap="square">
+            <a:spAutoFit/>
+          </a:bodyPr>
+          <a:lstStyle/>
+          <a:p>
+            <a:pPr algn="l"/>
+            <a:r>
+              <a:rPr sz="1100" b="1">
+                <a:solidFill>
+                  <a:srgbClr val="FFFFFF"/>
+                </a:solidFill>
+              </a:rPr>
+              <a:t>VAJADUSE SKOOR</a:t>
+            </a:r>
+          </a:p>
+        </p:txBody>
+      </p:sp>
+      <p:sp>
+        <p:nvSpPr>
+          <p:cNvPr id="14" name="TextBox 13"/>
+          <p:cNvSpPr txBox="1"/>
+          <p:nvPr/>
+        </p:nvSpPr>
+        <p:spPr>
+          <a:xfrm>
+            <a:off x="7836408" y="2953512"/>
+            <a:ext cx="3840480" cy="384048"/>
+          </a:xfrm>
+          <a:prstGeom prst="rect">
+            <a:avLst/>
+          </a:prstGeom>
+          <a:noFill/>
+        </p:spPr>
+        <p:txBody>
+          <a:bodyPr wrap="square">
+            <a:spAutoFit/>
+          </a:bodyPr>
+          <a:lstStyle/>
+          <a:p>
+            <a:pPr algn="l"/>
+            <a:r>
+              <a:rPr sz="1000" b="0">
+                <a:solidFill>
+                  <a:srgbClr val="BDD7EE"/>
+                </a:solidFill>
+              </a:rPr>
+              <a:t>soojakadu_kwh
+/ kogupindala_m²</a:t>
+            </a:r>
+          </a:p>
+        </p:txBody>
+      </p:sp>
+      <p:sp>
+        <p:nvSpPr>
+          <p:cNvPr id="15" name="Rectangle 14"/>
+          <p:cNvSpPr/>
+          <p:nvPr/>
+        </p:nvSpPr>
+        <p:spPr>
+          <a:xfrm>
+            <a:off x="7726679" y="3429000"/>
+            <a:ext cx="4069080" cy="749808"/>
+          </a:xfrm>
+          <a:prstGeom prst="rect">
+            <a:avLst/>
+          </a:prstGeom>
+          <a:solidFill>
+            <a:srgbClr val="2E75B6"/>
+          </a:solidFill>
+          <a:ln>
+            <a:noFill/>
+          </a:ln>
+        </p:spPr>
+        <p:style>
+          <a:lnRef idx="1">
+            <a:schemeClr val="accent1"/>
+          </a:lnRef>
+          <a:fillRef idx="3">
+            <a:schemeClr val="accent1"/>
+          </a:fillRef>
+          <a:effectRef idx="2">
+            <a:schemeClr val="accent1"/>
+          </a:effectRef>
+          <a:fontRef idx="minor">
+            <a:schemeClr val="lt1"/>
+          </a:fontRef>
+        </p:style>
+        <p:txBody>
+          <a:bodyPr rtlCol="0" anchor="ctr"/>
+          <a:lstStyle/>
+          <a:p>
+            <a:pPr algn="ctr"/>
+          </a:p>
+        </p:txBody>
+      </p:sp>
+      <p:sp>
+        <p:nvSpPr>
+          <p:cNvPr id="16" name="TextBox 15"/>
+          <p:cNvSpPr txBox="1"/>
+          <p:nvPr/>
+        </p:nvSpPr>
+        <p:spPr>
+          <a:xfrm>
+            <a:off x="7836408" y="3447288"/>
+            <a:ext cx="3840480" cy="320040"/>
+          </a:xfrm>
+          <a:prstGeom prst="rect">
+            <a:avLst/>
+          </a:prstGeom>
+          <a:noFill/>
+        </p:spPr>
+        <p:txBody>
+          <a:bodyPr wrap="square">
+            <a:spAutoFit/>
+          </a:bodyPr>
+          <a:lstStyle/>
+          <a:p>
+            <a:pPr algn="l"/>
+            <a:r>
+              <a:rPr sz="1100" b="1">
+                <a:solidFill>
+                  <a:srgbClr val="FFFFFF"/>
+                </a:solidFill>
+              </a:rPr>
+              <a:t>INVESTEERING</a:t>
+            </a:r>
+          </a:p>
+        </p:txBody>
+      </p:sp>
+      <p:sp>
+        <p:nvSpPr>
+          <p:cNvPr id="17" name="TextBox 16"/>
+          <p:cNvSpPr txBox="1"/>
+          <p:nvPr/>
+        </p:nvSpPr>
+        <p:spPr>
+          <a:xfrm>
+            <a:off x="7836408" y="3776472"/>
+            <a:ext cx="3840480" cy="384048"/>
+          </a:xfrm>
+          <a:prstGeom prst="rect">
+            <a:avLst/>
+          </a:prstGeom>
+          <a:noFill/>
+        </p:spPr>
+        <p:txBody>
+          <a:bodyPr wrap="square">
+            <a:spAutoFit/>
+          </a:bodyPr>
+          <a:lstStyle/>
+          <a:p>
+            <a:pPr algn="l"/>
+            <a:r>
+              <a:rPr sz="1000" b="0">
+                <a:solidFill>
+                  <a:srgbClr val="BDD7EE"/>
+                </a:solidFill>
+              </a:rPr>
+              <a:t>kogupindala_m² × 250
+(€/m² proxy)</a:t>
+            </a:r>
+          </a:p>
+        </p:txBody>
+      </p:sp>
+      <p:sp>
+        <p:nvSpPr>
+          <p:cNvPr id="18" name="Rectangle 17"/>
+          <p:cNvSpPr/>
+          <p:nvPr/>
+        </p:nvSpPr>
+        <p:spPr>
+          <a:xfrm>
+            <a:off x="7726679" y="4251960"/>
+            <a:ext cx="4069080" cy="749808"/>
+          </a:xfrm>
+          <a:prstGeom prst="rect">
+            <a:avLst/>
+          </a:prstGeom>
+          <a:solidFill>
+            <a:srgbClr val="2E75B6"/>
+          </a:solidFill>
+          <a:ln>
+            <a:noFill/>
+          </a:ln>
+        </p:spPr>
+        <p:style>
+          <a:lnRef idx="1">
+            <a:schemeClr val="accent1"/>
+          </a:lnRef>
+          <a:fillRef idx="3">
+            <a:schemeClr val="accent1"/>
+          </a:fillRef>
+          <a:effectRef idx="2">
+            <a:schemeClr val="accent1"/>
+          </a:effectRef>
+          <a:fontRef idx="minor">
+            <a:schemeClr val="lt1"/>
+          </a:fontRef>
+        </p:style>
+        <p:txBody>
+          <a:bodyPr rtlCol="0" anchor="ctr"/>
+          <a:lstStyle/>
+          <a:p>
+            <a:pPr algn="ctr"/>
+          </a:p>
+        </p:txBody>
+      </p:sp>
+      <p:sp>
+        <p:nvSpPr>
+          <p:cNvPr id="19" name="TextBox 18"/>
+          <p:cNvSpPr txBox="1"/>
+          <p:nvPr/>
+        </p:nvSpPr>
+        <p:spPr>
+          <a:xfrm>
+            <a:off x="7836408" y="4270248"/>
+            <a:ext cx="3840480" cy="320040"/>
+          </a:xfrm>
+          <a:prstGeom prst="rect">
+            <a:avLst/>
+          </a:prstGeom>
+          <a:noFill/>
+        </p:spPr>
+        <p:txBody>
+          <a:bodyPr wrap="square">
+            <a:spAutoFit/>
+          </a:bodyPr>
+          <a:lstStyle/>
+          <a:p>
+            <a:pPr algn="l"/>
+            <a:r>
+              <a:rPr sz="1100" b="1">
+                <a:solidFill>
+                  <a:srgbClr val="FFFFFF"/>
+                </a:solidFill>
+              </a:rPr>
+              <a:t>PRIORITY</a:t>
+            </a:r>
+          </a:p>
+        </p:txBody>
+      </p:sp>
+      <p:sp>
+        <p:nvSpPr>
+          <p:cNvPr id="20" name="TextBox 19"/>
+          <p:cNvSpPr txBox="1"/>
+          <p:nvPr/>
+        </p:nvSpPr>
+        <p:spPr>
+          <a:xfrm>
+            <a:off x="7836408" y="4599432"/>
+            <a:ext cx="3840480" cy="384048"/>
+          </a:xfrm>
+          <a:prstGeom prst="rect">
+            <a:avLst/>
+          </a:prstGeom>
+          <a:noFill/>
+        </p:spPr>
+        <p:txBody>
+          <a:bodyPr wrap="square">
+            <a:spAutoFit/>
+          </a:bodyPr>
+          <a:lstStyle/>
+          <a:p>
+            <a:pPr algn="l"/>
+            <a:r>
+              <a:rPr sz="1000" b="0">
+                <a:solidFill>
+                  <a:srgbClr val="BDD7EE"/>
+                </a:solidFill>
+              </a:rPr>
+              <a:t>LOG(sääst+1) × LOG(skoor+1)
+× LOG(pindala+1)</a:t>
+            </a:r>
+          </a:p>
+        </p:txBody>
+      </p:sp>
+      <p:sp>
+        <p:nvSpPr>
+          <p:cNvPr id="21" name="Rectangle 20"/>
+          <p:cNvSpPr/>
+          <p:nvPr/>
+        </p:nvSpPr>
+        <p:spPr>
+          <a:xfrm>
+            <a:off x="7726679" y="5074920"/>
+            <a:ext cx="4069080" cy="749808"/>
+          </a:xfrm>
+          <a:prstGeom prst="rect">
+            <a:avLst/>
+          </a:prstGeom>
+          <a:solidFill>
+            <a:srgbClr val="2E75B6"/>
+          </a:solidFill>
+          <a:ln>
+            <a:noFill/>
+          </a:ln>
+        </p:spPr>
+        <p:style>
+          <a:lnRef idx="1">
+            <a:schemeClr val="accent1"/>
+          </a:lnRef>
+          <a:fillRef idx="3">
+            <a:schemeClr val="accent1"/>
+          </a:fillRef>
+          <a:effectRef idx="2">
+            <a:schemeClr val="accent1"/>
+          </a:effectRef>
+          <a:fontRef idx="minor">
+            <a:schemeClr val="lt1"/>
+          </a:fontRef>
+        </p:style>
+        <p:txBody>
+          <a:bodyPr rtlCol="0" anchor="ctr"/>
+          <a:lstStyle/>
+          <a:p>
+            <a:pPr algn="ctr"/>
+          </a:p>
+        </p:txBody>
+      </p:sp>
+      <p:sp>
+        <p:nvSpPr>
+          <p:cNvPr id="22" name="TextBox 21"/>
+          <p:cNvSpPr txBox="1"/>
+          <p:nvPr/>
+        </p:nvSpPr>
+        <p:spPr>
+          <a:xfrm>
+            <a:off x="7836408" y="5093208"/>
+            <a:ext cx="3840480" cy="320040"/>
+          </a:xfrm>
+          <a:prstGeom prst="rect">
+            <a:avLst/>
+          </a:prstGeom>
+          <a:noFill/>
+        </p:spPr>
+        <p:txBody>
+          <a:bodyPr wrap="square">
+            <a:spAutoFit/>
+          </a:bodyPr>
+          <a:lstStyle/>
+          <a:p>
+            <a:pPr algn="l"/>
+            <a:r>
+              <a:rPr sz="1100" b="1">
+                <a:solidFill>
+                  <a:srgbClr val="FFFFFF"/>
+                </a:solidFill>
+              </a:rPr>
+              <a:t>TASUVUS</a:t>
+            </a:r>
+          </a:p>
+        </p:txBody>
+      </p:sp>
+      <p:sp>
+        <p:nvSpPr>
+          <p:cNvPr id="23" name="TextBox 22"/>
+          <p:cNvSpPr txBox="1"/>
+          <p:nvPr/>
+        </p:nvSpPr>
+        <p:spPr>
+          <a:xfrm>
+            <a:off x="7836408" y="5422392"/>
+            <a:ext cx="3840480" cy="384048"/>
+          </a:xfrm>
+          <a:prstGeom prst="rect">
+            <a:avLst/>
+          </a:prstGeom>
+          <a:noFill/>
+        </p:spPr>
+        <p:txBody>
+          <a:bodyPr wrap="square">
+            <a:spAutoFit/>
+          </a:bodyPr>
+          <a:lstStyle/>
+          <a:p>
+            <a:pPr algn="l"/>
+            <a:r>
+              <a:rPr sz="1000" b="0">
+                <a:solidFill>
+                  <a:srgbClr val="BDD7EE"/>
+                </a:solidFill>
+              </a:rPr>
+              <a:t>1 / NULLIF(roi, 0)</a:t>
+            </a:r>
+          </a:p>
+        </p:txBody>
+      </p:sp>
+    </p:spTree>
+  </p:cSld>
+  <p:clrMapOvr>
+    <a:masterClrMapping/>
+  </p:clrMapOvr>
+</p:sld>
+</file>
+
+<file path=ppt/slides/slide9.xml><?xml version="1.0" encoding="utf-8"?>
+<p:sld xmlns:a="http://schemas.openxmlformats.org/drawingml/2006/main" xmlns:p="http://schemas.openxmlformats.org/presentationml/2006/main" xmlns:r="http://schemas.openxmlformats.org/officeDocument/2006/relationships">
+  <p:cSld>
+    <p:bg>
+      <p:bgPr>
+        <a:solidFill>
+          <a:srgbClr val="FFFFFF"/>
+        </a:solidFill>
+        <a:effectLst/>
+      </p:bgPr>
+    </p:bg>
+    <p:spTree>
+      <p:nvGrpSpPr>
+        <p:cNvPr id="1" name=""/>
+        <p:cNvGrpSpPr/>
+        <p:nvPr/>
+      </p:nvGrpSpPr>
+      <p:grpSpPr/>
+      <p:sp>
+        <p:nvSpPr>
+          <p:cNvPr id="2" name="Rectangle 1"/>
+          <p:cNvSpPr/>
+          <p:nvPr/>
+        </p:nvSpPr>
+        <p:spPr>
+          <a:xfrm>
+            <a:off x="0" y="0"/>
+            <a:ext cx="12188952" cy="1005840"/>
+          </a:xfrm>
+          <a:prstGeom prst="rect">
+            <a:avLst/>
+          </a:prstGeom>
+          <a:solidFill>
+            <a:srgbClr val="1B376B"/>
+          </a:solidFill>
+          <a:ln>
+            <a:noFill/>
+          </a:ln>
+        </p:spPr>
+        <p:style>
+          <a:lnRef idx="1">
+            <a:schemeClr val="accent1"/>
+          </a:lnRef>
+          <a:fillRef idx="3">
+            <a:schemeClr val="accent1"/>
+          </a:fillRef>
+          <a:effectRef idx="2">
+            <a:schemeClr val="accent1"/>
+          </a:effectRef>
+          <a:fontRef idx="minor">
+            <a:schemeClr val="lt1"/>
+          </a:fontRef>
+        </p:style>
+        <p:txBody>
+          <a:bodyPr rtlCol="0" anchor="ctr"/>
+          <a:lstStyle/>
+          <a:p>
+            <a:pPr algn="ctr"/>
+          </a:p>
+        </p:txBody>
+      </p:sp>
+      <p:sp>
+        <p:nvSpPr>
+          <p:cNvPr id="3" name="TextBox 2"/>
+          <p:cNvSpPr txBox="1"/>
+          <p:nvPr/>
+        </p:nvSpPr>
+        <p:spPr>
+          <a:xfrm>
+            <a:off x="365760" y="91440"/>
+            <a:ext cx="11430000" cy="777240"/>
+          </a:xfrm>
+          <a:prstGeom prst="rect">
+            <a:avLst/>
+          </a:prstGeom>
+          <a:noFill/>
+        </p:spPr>
+        <p:txBody>
+          <a:bodyPr wrap="square">
+            <a:spAutoFit/>
+          </a:bodyPr>
+          <a:lstStyle/>
+          <a:p>
+            <a:pPr algn="l"/>
+            <a:r>
+              <a:rPr sz="2800" b="1">
+                <a:solidFill>
+                  <a:srgbClr val="FFFFFF"/>
+                </a:solidFill>
+              </a:rPr>
+              <a:t>Dashboard: põhitulemused</a:t>
+            </a:r>
+          </a:p>
+        </p:txBody>
+      </p:sp>
+      <p:sp>
+        <p:nvSpPr>
+          <p:cNvPr id="4" name="Rectangle 3"/>
+          <p:cNvSpPr/>
+          <p:nvPr/>
+        </p:nvSpPr>
+        <p:spPr>
+          <a:xfrm>
+            <a:off x="274320" y="1143000"/>
+            <a:ext cx="2697480" cy="1371600"/>
+          </a:xfrm>
+          <a:prstGeom prst="rect">
+            <a:avLst/>
+          </a:prstGeom>
+          <a:solidFill>
+            <a:srgbClr val="1B376B"/>
+          </a:solidFill>
+          <a:ln>
+            <a:noFill/>
+          </a:ln>
+        </p:spPr>
+        <p:style>
+          <a:lnRef idx="1">
+            <a:schemeClr val="accent1"/>
+          </a:lnRef>
+          <a:fillRef idx="3">
+            <a:schemeClr val="accent1"/>
+          </a:fillRef>
+          <a:effectRef idx="2">
+            <a:schemeClr val="accent1"/>
+          </a:effectRef>
+          <a:fontRef idx="minor">
+            <a:schemeClr val="lt1"/>
+          </a:fontRef>
+        </p:style>
+        <p:txBody>
+          <a:bodyPr rtlCol="0" anchor="ctr"/>
+          <a:lstStyle/>
+          <a:p>
+            <a:pPr algn="ctr"/>
+          </a:p>
+        </p:txBody>
+      </p:sp>
+      <p:sp>
+        <p:nvSpPr>
+          <p:cNvPr id="5" name="TextBox 4"/>
+          <p:cNvSpPr txBox="1"/>
+          <p:nvPr/>
+        </p:nvSpPr>
+        <p:spPr>
+          <a:xfrm>
+            <a:off x="365760" y="1188720"/>
+            <a:ext cx="2514600" cy="502920"/>
+          </a:xfrm>
+          <a:prstGeom prst="rect">
+            <a:avLst/>
+          </a:prstGeom>
+          <a:noFill/>
+        </p:spPr>
+        <p:txBody>
+          <a:bodyPr wrap="square">
+            <a:spAutoFit/>
+          </a:bodyPr>
+          <a:lstStyle/>
+          <a:p>
+            <a:pPr algn="ctr"/>
+            <a:r>
+              <a:rPr sz="1300" b="0">
+                <a:solidFill>
+                  <a:srgbClr val="FFFFFF"/>
+                </a:solidFill>
+              </a:rPr>
+              <a:t>Soojakadu Eestis</a:t>
+            </a:r>
+          </a:p>
+        </p:txBody>
+      </p:sp>
+      <p:sp>
+        <p:nvSpPr>
+          <p:cNvPr id="6" name="TextBox 5"/>
+          <p:cNvSpPr txBox="1"/>
+          <p:nvPr/>
+        </p:nvSpPr>
+        <p:spPr>
+          <a:xfrm>
+            <a:off x="320040" y="1691640"/>
+            <a:ext cx="2606040" cy="685800"/>
+          </a:xfrm>
+          <a:prstGeom prst="rect">
+            <a:avLst/>
+          </a:prstGeom>
+          <a:noFill/>
+        </p:spPr>
+        <p:txBody>
+          <a:bodyPr wrap="square">
+            <a:spAutoFit/>
+          </a:bodyPr>
+          <a:lstStyle/>
+          <a:p>
+            <a:pPr algn="ctr"/>
+            <a:r>
+              <a:rPr sz="2200" b="1">
+                <a:solidFill>
+                  <a:srgbClr val="FFFFFF"/>
+                </a:solidFill>
+              </a:rPr>
+              <a:t>9.26B kWh</a:t>
+            </a:r>
+          </a:p>
+        </p:txBody>
+      </p:sp>
+      <p:sp>
+        <p:nvSpPr>
+          <p:cNvPr id="7" name="Rectangle 6"/>
+          <p:cNvSpPr/>
+          <p:nvPr/>
+        </p:nvSpPr>
+        <p:spPr>
+          <a:xfrm>
+            <a:off x="3182112" y="1143000"/>
+            <a:ext cx="2697480" cy="1371600"/>
+          </a:xfrm>
+          <a:prstGeom prst="rect">
+            <a:avLst/>
+          </a:prstGeom>
+          <a:solidFill>
+            <a:srgbClr val="2E75B6"/>
+          </a:solidFill>
+          <a:ln>
+            <a:noFill/>
+          </a:ln>
+        </p:spPr>
+        <p:style>
+          <a:lnRef idx="1">
+            <a:schemeClr val="accent1"/>
+          </a:lnRef>
+          <a:fillRef idx="3">
+            <a:schemeClr val="accent1"/>
+          </a:fillRef>
+          <a:effectRef idx="2">
+            <a:schemeClr val="accent1"/>
+          </a:effectRef>
+          <a:fontRef idx="minor">
+            <a:schemeClr val="lt1"/>
+          </a:fontRef>
+        </p:style>
+        <p:txBody>
+          <a:bodyPr rtlCol="0" anchor="ctr"/>
+          <a:lstStyle/>
+          <a:p>
+            <a:pPr algn="ctr"/>
+          </a:p>
+        </p:txBody>
+      </p:sp>
+      <p:sp>
+        <p:nvSpPr>
+          <p:cNvPr id="8" name="TextBox 7"/>
+          <p:cNvSpPr txBox="1"/>
+          <p:nvPr/>
+        </p:nvSpPr>
+        <p:spPr>
+          <a:xfrm>
+            <a:off x="3273552" y="1188720"/>
+            <a:ext cx="2514600" cy="502920"/>
+          </a:xfrm>
+          <a:prstGeom prst="rect">
+            <a:avLst/>
+          </a:prstGeom>
+          <a:noFill/>
+        </p:spPr>
+        <p:txBody>
+          <a:bodyPr wrap="square">
+            <a:spAutoFit/>
+          </a:bodyPr>
+          <a:lstStyle/>
+          <a:p>
+            <a:pPr algn="ctr"/>
+            <a:r>
+              <a:rPr sz="1300" b="0">
+                <a:solidFill>
+                  <a:srgbClr val="FFFFFF"/>
+                </a:solidFill>
+              </a:rPr>
+              <a:t>Kulu</a:t>
+            </a:r>
+          </a:p>
+        </p:txBody>
+      </p:sp>
+      <p:sp>
+        <p:nvSpPr>
+          <p:cNvPr id="9" name="TextBox 8"/>
+          <p:cNvSpPr txBox="1"/>
+          <p:nvPr/>
+        </p:nvSpPr>
+        <p:spPr>
+          <a:xfrm>
+            <a:off x="3227832" y="1691640"/>
+            <a:ext cx="2606040" cy="685800"/>
+          </a:xfrm>
+          <a:prstGeom prst="rect">
+            <a:avLst/>
+          </a:prstGeom>
+          <a:noFill/>
+        </p:spPr>
+        <p:txBody>
+          <a:bodyPr wrap="square">
+            <a:spAutoFit/>
+          </a:bodyPr>
+          <a:lstStyle/>
+          <a:p>
+            <a:pPr algn="ctr"/>
+            <a:r>
+              <a:rPr sz="2200" b="1">
+                <a:solidFill>
+                  <a:srgbClr val="FFFFFF"/>
+                </a:solidFill>
+              </a:rPr>
+              <a:t>660M €</a:t>
+            </a:r>
+          </a:p>
+        </p:txBody>
+      </p:sp>
+      <p:sp>
+        <p:nvSpPr>
+          <p:cNvPr id="10" name="Rectangle 9"/>
+          <p:cNvSpPr/>
+          <p:nvPr/>
+        </p:nvSpPr>
+        <p:spPr>
+          <a:xfrm>
+            <a:off x="6089904" y="1143000"/>
+            <a:ext cx="2697480" cy="1371600"/>
+          </a:xfrm>
+          <a:prstGeom prst="rect">
+            <a:avLst/>
+          </a:prstGeom>
+          <a:solidFill>
+            <a:srgbClr val="5A9E6F"/>
+          </a:solidFill>
+          <a:ln>
+            <a:noFill/>
+          </a:ln>
+        </p:spPr>
+        <p:style>
+          <a:lnRef idx="1">
+            <a:schemeClr val="accent1"/>
+          </a:lnRef>
+          <a:fillRef idx="3">
+            <a:schemeClr val="accent1"/>
+          </a:fillRef>
+          <a:effectRef idx="2">
+            <a:schemeClr val="accent1"/>
+          </a:effectRef>
+          <a:fontRef idx="minor">
+            <a:schemeClr val="lt1"/>
+          </a:fontRef>
+        </p:style>
+        <p:txBody>
+          <a:bodyPr rtlCol="0" anchor="ctr"/>
+          <a:lstStyle/>
+          <a:p>
+            <a:pPr algn="ctr"/>
+          </a:p>
+        </p:txBody>
+      </p:sp>
+      <p:sp>
+        <p:nvSpPr>
+          <p:cNvPr id="11" name="TextBox 10"/>
+          <p:cNvSpPr txBox="1"/>
+          <p:nvPr/>
+        </p:nvSpPr>
+        <p:spPr>
+          <a:xfrm>
+            <a:off x="6181344" y="1188720"/>
+            <a:ext cx="2514600" cy="502920"/>
+          </a:xfrm>
+          <a:prstGeom prst="rect">
+            <a:avLst/>
+          </a:prstGeom>
+          <a:noFill/>
+        </p:spPr>
+        <p:txBody>
+          <a:bodyPr wrap="square">
+            <a:spAutoFit/>
+          </a:bodyPr>
+          <a:lstStyle/>
+          <a:p>
+            <a:pPr algn="ctr"/>
+            <a:r>
+              <a:rPr sz="1300" b="0">
+                <a:solidFill>
+                  <a:srgbClr val="FFFFFF"/>
+                </a:solidFill>
+              </a:rPr>
+              <a:t>Säästupotentsiaal</a:t>
+            </a:r>
+          </a:p>
+        </p:txBody>
+      </p:sp>
+      <p:sp>
+        <p:nvSpPr>
+          <p:cNvPr id="12" name="TextBox 11"/>
+          <p:cNvSpPr txBox="1"/>
+          <p:nvPr/>
+        </p:nvSpPr>
+        <p:spPr>
+          <a:xfrm>
+            <a:off x="6135624" y="1691640"/>
+            <a:ext cx="2606040" cy="685800"/>
+          </a:xfrm>
+          <a:prstGeom prst="rect">
+            <a:avLst/>
+          </a:prstGeom>
+          <a:noFill/>
+        </p:spPr>
+        <p:txBody>
+          <a:bodyPr wrap="square">
+            <a:spAutoFit/>
+          </a:bodyPr>
+          <a:lstStyle/>
+          <a:p>
+            <a:pPr algn="ctr"/>
+            <a:r>
+              <a:rPr sz="2200" b="1">
+                <a:solidFill>
+                  <a:srgbClr val="FFFFFF"/>
+                </a:solidFill>
+              </a:rPr>
+              <a:t>423M €/aastas</a:t>
+            </a:r>
+          </a:p>
+        </p:txBody>
+      </p:sp>
+      <p:sp>
+        <p:nvSpPr>
+          <p:cNvPr id="13" name="Rectangle 12"/>
+          <p:cNvSpPr/>
+          <p:nvPr/>
+        </p:nvSpPr>
+        <p:spPr>
+          <a:xfrm>
+            <a:off x="8997696" y="1143000"/>
+            <a:ext cx="2697480" cy="1371600"/>
+          </a:xfrm>
+          <a:prstGeom prst="rect">
+            <a:avLst/>
+          </a:prstGeom>
+          <a:solidFill>
+            <a:srgbClr val="ED7D31"/>
+          </a:solidFill>
+          <a:ln>
+            <a:noFill/>
+          </a:ln>
+        </p:spPr>
+        <p:style>
+          <a:lnRef idx="1">
+            <a:schemeClr val="accent1"/>
+          </a:lnRef>
+          <a:fillRef idx="3">
+            <a:schemeClr val="accent1"/>
+          </a:fillRef>
+          <a:effectRef idx="2">
+            <a:schemeClr val="accent1"/>
+          </a:effectRef>
+          <a:fontRef idx="minor">
+            <a:schemeClr val="lt1"/>
+          </a:fontRef>
+        </p:style>
+        <p:txBody>
+          <a:bodyPr rtlCol="0" anchor="ctr"/>
+          <a:lstStyle/>
+          <a:p>
+            <a:pPr algn="ctr"/>
+          </a:p>
+        </p:txBody>
+      </p:sp>
+      <p:sp>
+        <p:nvSpPr>
+          <p:cNvPr id="14" name="TextBox 13"/>
+          <p:cNvSpPr txBox="1"/>
+          <p:nvPr/>
+        </p:nvSpPr>
+        <p:spPr>
+          <a:xfrm>
+            <a:off x="9089136" y="1188720"/>
+            <a:ext cx="2514600" cy="502920"/>
+          </a:xfrm>
+          <a:prstGeom prst="rect">
+            <a:avLst/>
+          </a:prstGeom>
+          <a:noFill/>
+        </p:spPr>
+        <p:txBody>
+          <a:bodyPr wrap="square">
+            <a:spAutoFit/>
+          </a:bodyPr>
+          <a:lstStyle/>
+          <a:p>
+            <a:pPr algn="ctr"/>
+            <a:r>
+              <a:rPr sz="1300" b="0">
+                <a:solidFill>
+                  <a:srgbClr val="FFFFFF"/>
+                </a:solidFill>
+              </a:rPr>
+              <a:t>Keskmine intensiivsus</a:t>
+            </a:r>
+          </a:p>
+        </p:txBody>
+      </p:sp>
+      <p:sp>
+        <p:nvSpPr>
+          <p:cNvPr id="15" name="TextBox 14"/>
+          <p:cNvSpPr txBox="1"/>
+          <p:nvPr/>
+        </p:nvSpPr>
+        <p:spPr>
+          <a:xfrm>
+            <a:off x="9043416" y="1691640"/>
+            <a:ext cx="2606040" cy="685800"/>
+          </a:xfrm>
+          <a:prstGeom prst="rect">
+            <a:avLst/>
+          </a:prstGeom>
+          <a:noFill/>
+        </p:spPr>
+        <p:txBody>
+          <a:bodyPr wrap="square">
+            <a:spAutoFit/>
+          </a:bodyPr>
+          <a:lstStyle/>
+          <a:p>
+            <a:pPr algn="ctr"/>
+            <a:r>
+              <a:rPr sz="2200" b="1">
+                <a:solidFill>
+                  <a:srgbClr val="FFFFFF"/>
+                </a:solidFill>
+              </a:rPr>
+              <a:t>149.93 kWh/m²</a:t>
+            </a:r>
+          </a:p>
+        </p:txBody>
+      </p:sp>
+      <p:sp>
+        <p:nvSpPr>
+          <p:cNvPr id="16" name="Rectangle 15"/>
+          <p:cNvSpPr/>
+          <p:nvPr/>
+        </p:nvSpPr>
+        <p:spPr>
+          <a:xfrm>
+            <a:off x="274320" y="2743200"/>
+            <a:ext cx="3794760" cy="3474720"/>
+          </a:xfrm>
+          <a:prstGeom prst="rect">
+            <a:avLst/>
+          </a:prstGeom>
+          <a:solidFill>
+            <a:srgbClr val="F2F2F2"/>
+          </a:solidFill>
+          <a:ln>
+            <a:noFill/>
+          </a:ln>
+        </p:spPr>
+        <p:style>
+          <a:lnRef idx="1">
+            <a:schemeClr val="accent1"/>
+          </a:lnRef>
+          <a:fillRef idx="3">
+            <a:schemeClr val="accent1"/>
+          </a:fillRef>
+          <a:effectRef idx="2">
+            <a:schemeClr val="accent1"/>
+          </a:effectRef>
+          <a:fontRef idx="minor">
+            <a:schemeClr val="lt1"/>
+          </a:fontRef>
+        </p:style>
+        <p:txBody>
+          <a:bodyPr rtlCol="0" anchor="ctr"/>
+          <a:lstStyle/>
+          <a:p>
+            <a:pPr algn="ctr"/>
+          </a:p>
+        </p:txBody>
+      </p:sp>
+      <p:sp>
+        <p:nvSpPr>
+          <p:cNvPr id="17" name="TextBox 16"/>
+          <p:cNvSpPr txBox="1"/>
+          <p:nvPr/>
+        </p:nvSpPr>
+        <p:spPr>
+          <a:xfrm>
+            <a:off x="384048" y="2807208"/>
+            <a:ext cx="3566160" cy="594360"/>
+          </a:xfrm>
+          <a:prstGeom prst="rect">
+            <a:avLst/>
+          </a:prstGeom>
+          <a:noFill/>
+        </p:spPr>
+        <p:txBody>
+          <a:bodyPr wrap="square">
+            <a:spAutoFit/>
+          </a:bodyPr>
+          <a:lstStyle/>
+          <a:p>
+            <a:pPr algn="l"/>
+            <a:r>
+              <a:rPr sz="1200" b="1">
+                <a:solidFill>
+                  <a:srgbClr val="2E75B6"/>
+                </a:solidFill>
+              </a:rPr>
+              <a:t>Suurim vajadus renoveerimiseks (vajaduse skoor)</a:t>
+            </a:r>
+          </a:p>
+        </p:txBody>
+      </p:sp>
+      <p:sp>
+        <p:nvSpPr>
+          <p:cNvPr id="18" name="TextBox 17"/>
+          <p:cNvSpPr txBox="1"/>
+          <p:nvPr/>
+        </p:nvSpPr>
+        <p:spPr>
+          <a:xfrm>
+            <a:off x="384048" y="3429000"/>
+            <a:ext cx="3566160" cy="2651760"/>
+          </a:xfrm>
+          <a:prstGeom prst="rect">
+            <a:avLst/>
+          </a:prstGeom>
+          <a:noFill/>
+        </p:spPr>
+        <p:txBody>
+          <a:bodyPr wrap="square">
+            <a:spAutoFit/>
+          </a:bodyPr>
+          <a:lstStyle/>
+          <a:p>
+            <a:pPr algn="l"/>
+            <a:r>
+              <a:rPr sz="1200" b="0">
+                <a:solidFill>
+                  <a:srgbClr val="404040"/>
+                </a:solidFill>
+              </a:rPr>
+              <a:t>Lääneranna vald · Kihnu vald · Räpina vald · Toila vald · Kanepi vald
+Mõõdik: soojakadu_kwh_aastas / kogupindala_m²</a:t>
+            </a:r>
+          </a:p>
+        </p:txBody>
+      </p:sp>
+      <p:sp>
+        <p:nvSpPr>
+          <p:cNvPr id="19" name="Rectangle 18"/>
+          <p:cNvSpPr/>
+          <p:nvPr/>
+        </p:nvSpPr>
+        <p:spPr>
+          <a:xfrm>
+            <a:off x="4251959" y="2743200"/>
+            <a:ext cx="3794760" cy="3474720"/>
+          </a:xfrm>
+          <a:prstGeom prst="rect">
+            <a:avLst/>
+          </a:prstGeom>
+          <a:solidFill>
+            <a:srgbClr val="F2F2F2"/>
+          </a:solidFill>
+          <a:ln>
+            <a:noFill/>
+          </a:ln>
+        </p:spPr>
+        <p:style>
+          <a:lnRef idx="1">
+            <a:schemeClr val="accent1"/>
+          </a:lnRef>
+          <a:fillRef idx="3">
+            <a:schemeClr val="accent1"/>
+          </a:fillRef>
+          <a:effectRef idx="2">
+            <a:schemeClr val="accent1"/>
+          </a:effectRef>
+          <a:fontRef idx="minor">
+            <a:schemeClr val="lt1"/>
+          </a:fontRef>
+        </p:style>
+        <p:txBody>
+          <a:bodyPr rtlCol="0" anchor="ctr"/>
+          <a:lstStyle/>
+          <a:p>
+            <a:pPr algn="ctr"/>
+          </a:p>
+        </p:txBody>
+      </p:sp>
+      <p:sp>
+        <p:nvSpPr>
+          <p:cNvPr id="20" name="TextBox 19"/>
+          <p:cNvSpPr txBox="1"/>
+          <p:nvPr/>
+        </p:nvSpPr>
+        <p:spPr>
+          <a:xfrm>
+            <a:off x="4361688" y="2807208"/>
+            <a:ext cx="3566160" cy="594360"/>
+          </a:xfrm>
+          <a:prstGeom prst="rect">
+            <a:avLst/>
+          </a:prstGeom>
+          <a:noFill/>
+        </p:spPr>
+        <p:txBody>
+          <a:bodyPr wrap="square">
+            <a:spAutoFit/>
+          </a:bodyPr>
+          <a:lstStyle/>
+          <a:p>
+            <a:pPr algn="l"/>
+            <a:r>
+              <a:rPr sz="1200" b="1">
+                <a:solidFill>
+                  <a:srgbClr val="2E75B6"/>
+                </a:solidFill>
+              </a:rPr>
+              <a:t>TOP 10 KOV — suurim aastane säästupotentsiaal (€)</a:t>
+            </a:r>
+          </a:p>
+        </p:txBody>
+      </p:sp>
+      <p:sp>
+        <p:nvSpPr>
+          <p:cNvPr id="21" name="TextBox 20"/>
+          <p:cNvSpPr txBox="1"/>
+          <p:nvPr/>
+        </p:nvSpPr>
+        <p:spPr>
+          <a:xfrm>
+            <a:off x="4361688" y="3429000"/>
+            <a:ext cx="3566160" cy="2651760"/>
+          </a:xfrm>
+          <a:prstGeom prst="rect">
+            <a:avLst/>
+          </a:prstGeom>
+          <a:noFill/>
+        </p:spPr>
+        <p:txBody>
+          <a:bodyPr wrap="square">
+            <a:spAutoFit/>
+          </a:bodyPr>
+          <a:lstStyle/>
+          <a:p>
+            <a:pPr algn="l"/>
+            <a:r>
+              <a:rPr sz="1200" b="0">
+                <a:solidFill>
+                  <a:srgbClr val="404040"/>
+                </a:solidFill>
+              </a:rPr>
+              <a:t>Tallinn ~100M € · Tartu linn ~20M € · Pärnu linn · Narva linn
+Kohtla-Järve · Saaremaa vald · Viljandi vald · Jõgeva vald · Elva vald</a:t>
+            </a:r>
+          </a:p>
+        </p:txBody>
+      </p:sp>
+      <p:sp>
+        <p:nvSpPr>
+          <p:cNvPr id="22" name="Rectangle 21"/>
+          <p:cNvSpPr/>
+          <p:nvPr/>
+        </p:nvSpPr>
+        <p:spPr>
+          <a:xfrm>
+            <a:off x="8229600" y="2743200"/>
+            <a:ext cx="3794760" cy="3474720"/>
+          </a:xfrm>
+          <a:prstGeom prst="rect">
+            <a:avLst/>
+          </a:prstGeom>
+          <a:solidFill>
+            <a:srgbClr val="F2F2F2"/>
+          </a:solidFill>
+          <a:ln>
+            <a:noFill/>
+          </a:ln>
+        </p:spPr>
+        <p:style>
+          <a:lnRef idx="1">
+            <a:schemeClr val="accent1"/>
+          </a:lnRef>
+          <a:fillRef idx="3">
+            <a:schemeClr val="accent1"/>
+          </a:fillRef>
+          <a:effectRef idx="2">
+            <a:schemeClr val="accent1"/>
+          </a:effectRef>
+          <a:fontRef idx="minor">
+            <a:schemeClr val="lt1"/>
+          </a:fontRef>
+        </p:style>
+        <p:txBody>
+          <a:bodyPr rtlCol="0" anchor="ctr"/>
+          <a:lstStyle/>
+          <a:p>
+            <a:pPr algn="ctr"/>
+          </a:p>
+        </p:txBody>
+      </p:sp>
+      <p:sp>
+        <p:nvSpPr>
+          <p:cNvPr id="23" name="TextBox 22"/>
+          <p:cNvSpPr txBox="1"/>
+          <p:nvPr/>
+        </p:nvSpPr>
+        <p:spPr>
+          <a:xfrm>
+            <a:off x="8339327" y="2807208"/>
+            <a:ext cx="3566160" cy="594360"/>
+          </a:xfrm>
+          <a:prstGeom prst="rect">
+            <a:avLst/>
+          </a:prstGeom>
+          <a:noFill/>
+        </p:spPr>
+        <p:txBody>
+          <a:bodyPr wrap="square">
+            <a:spAutoFit/>
+          </a:bodyPr>
+          <a:lstStyle/>
+          <a:p>
+            <a:pPr algn="l"/>
+            <a:r>
+              <a:rPr sz="1200" b="1">
+                <a:solidFill>
+                  <a:srgbClr val="2E75B6"/>
+                </a:solidFill>
+              </a:rPr>
+              <a:t>Investeeringu tasuvus — ROI vs tasuvusaeg</a:t>
+            </a:r>
+          </a:p>
+        </p:txBody>
+      </p:sp>
+      <p:sp>
+        <p:nvSpPr>
+          <p:cNvPr id="24" name="TextBox 23"/>
+          <p:cNvSpPr txBox="1"/>
+          <p:nvPr/>
+        </p:nvSpPr>
+        <p:spPr>
+          <a:xfrm>
+            <a:off x="8339327" y="3429000"/>
+            <a:ext cx="3566160" cy="2651760"/>
+          </a:xfrm>
+          <a:prstGeom prst="rect">
+            <a:avLst/>
+          </a:prstGeom>
+          <a:noFill/>
+        </p:spPr>
+        <p:txBody>
+          <a:bodyPr wrap="square">
+            <a:spAutoFit/>
+          </a:bodyPr>
+          <a:lstStyle/>
+          <a:p>
+            <a:pPr algn="l"/>
+            <a:r>
+              <a:rPr sz="1200" b="0">
+                <a:solidFill>
+                  <a:srgbClr val="404040"/>
+                </a:solidFill>
+              </a:rPr>
+              <a:t>Kambja vald (ROI 3.4) · Saue vald (3.36) · Tori vald (3.31)
+Rapla vald (3.21) — finantsiliselt kõige tasuvam renoveerimine</a:t>
             </a:r>
           </a:p>
         </p:txBody>

</xml_diff>